<commit_message>
feat(presentation): add tree flowchart with decision logic and tech stack column to Technical Approach slide
</commit_message>
<xml_diff>
--- a/TRACE_SIH_Presentation.pptx
+++ b/TRACE_SIH_Presentation.pptx
@@ -4278,80 +4278,8 @@
         </p:nvSpPr>
         <p:spPr>
           <a:xfrm>
-            <a:off x="548640" y="320040"/>
+            <a:off x="548640" y="274320"/>
             <a:ext cx="2011680" cy="640080"/>
-          </a:xfrm>
-          <a:prstGeom prst="rect">
-            <a:avLst/>
-          </a:prstGeom>
-          <a:noFill/>
-        </p:spPr>
-        <p:txBody>
-          <a:bodyPr wrap="square">
-            <a:spAutoFit/>
-          </a:bodyPr>
-          <a:lstStyle/>
-          <a:p>
-            <a:pPr>
-              <a:defRPr sz="2600" b="1">
-                <a:solidFill>
-                  <a:srgbClr val="109566"/>
-                </a:solidFill>
-                <a:latin typeface="Impact"/>
-              </a:defRPr>
-            </a:pPr>
-            <a:r>
-              <a:t>TRACE</a:t>
-            </a:r>
-          </a:p>
-        </p:txBody>
-      </p:sp>
-      <p:sp>
-        <p:nvSpPr>
-          <p:cNvPr id="3" name="TextBox 2"/>
-          <p:cNvSpPr txBox="1"/>
-          <p:nvPr/>
-        </p:nvSpPr>
-        <p:spPr>
-          <a:xfrm>
-            <a:off x="2560320" y="365760"/>
-            <a:ext cx="7315200" cy="731520"/>
-          </a:xfrm>
-          <a:prstGeom prst="rect">
-            <a:avLst/>
-          </a:prstGeom>
-          <a:noFill/>
-        </p:spPr>
-        <p:txBody>
-          <a:bodyPr wrap="square">
-            <a:spAutoFit/>
-          </a:bodyPr>
-          <a:lstStyle/>
-          <a:p>
-            <a:pPr algn="ctr">
-              <a:defRPr sz="2600" b="1">
-                <a:solidFill>
-                  <a:srgbClr val="0F2942"/>
-                </a:solidFill>
-                <a:latin typeface="Times New Roman"/>
-              </a:defRPr>
-            </a:pPr>
-            <a:r>
-              <a:t>TECHNICAL APPROACH</a:t>
-            </a:r>
-          </a:p>
-        </p:txBody>
-      </p:sp>
-      <p:sp>
-        <p:nvSpPr>
-          <p:cNvPr id="4" name="TextBox 3"/>
-          <p:cNvSpPr txBox="1"/>
-          <p:nvPr/>
-        </p:nvSpPr>
-        <p:spPr>
-          <a:xfrm>
-            <a:off x="10058400" y="228600"/>
-            <a:ext cx="1828800" cy="822960"/>
           </a:xfrm>
           <a:prstGeom prst="rect">
             <a:avLst/>
@@ -4364,6 +4292,78 @@
           </a:bodyPr>
           <a:lstStyle/>
           <a:p>
+            <a:pPr>
+              <a:defRPr sz="2600" b="1">
+                <a:solidFill>
+                  <a:srgbClr val="109566"/>
+                </a:solidFill>
+                <a:latin typeface="Impact"/>
+              </a:defRPr>
+            </a:pPr>
+            <a:r>
+              <a:t>TRACE</a:t>
+            </a:r>
+          </a:p>
+        </p:txBody>
+      </p:sp>
+      <p:sp>
+        <p:nvSpPr>
+          <p:cNvPr id="3" name="TextBox 2"/>
+          <p:cNvSpPr txBox="1"/>
+          <p:nvPr/>
+        </p:nvSpPr>
+        <p:spPr>
+          <a:xfrm>
+            <a:off x="2560320" y="320040"/>
+            <a:ext cx="6858000" cy="731520"/>
+          </a:xfrm>
+          <a:prstGeom prst="rect">
+            <a:avLst/>
+          </a:prstGeom>
+          <a:noFill/>
+        </p:spPr>
+        <p:txBody>
+          <a:bodyPr wrap="none">
+            <a:spAutoFit/>
+          </a:bodyPr>
+          <a:lstStyle/>
+          <a:p>
+            <a:pPr algn="ctr">
+              <a:defRPr sz="2600" b="1">
+                <a:solidFill>
+                  <a:srgbClr val="0F2942"/>
+                </a:solidFill>
+                <a:latin typeface="Times New Roman"/>
+              </a:defRPr>
+            </a:pPr>
+            <a:r>
+              <a:t>TECHNICAL APPROACH</a:t>
+            </a:r>
+          </a:p>
+        </p:txBody>
+      </p:sp>
+      <p:sp>
+        <p:nvSpPr>
+          <p:cNvPr id="4" name="TextBox 3"/>
+          <p:cNvSpPr txBox="1"/>
+          <p:nvPr/>
+        </p:nvSpPr>
+        <p:spPr>
+          <a:xfrm>
+            <a:off x="10058400" y="182880"/>
+            <a:ext cx="1828800" cy="822960"/>
+          </a:xfrm>
+          <a:prstGeom prst="rect">
+            <a:avLst/>
+          </a:prstGeom>
+          <a:noFill/>
+        </p:spPr>
+        <p:txBody>
+          <a:bodyPr wrap="none">
+            <a:spAutoFit/>
+          </a:bodyPr>
+          <a:lstStyle/>
+          <a:p>
             <a:pPr algn="r">
               <a:defRPr sz="1300" b="1">
                 <a:solidFill>
@@ -4404,6 +4404,3879 @@
       <p:sp>
         <p:nvSpPr>
           <p:cNvPr id="5" name="Rounded Rectangle 4"/>
+          <p:cNvSpPr/>
+          <p:nvPr/>
+        </p:nvSpPr>
+        <p:spPr>
+          <a:xfrm>
+            <a:off x="457200" y="3246120"/>
+            <a:ext cx="868680" cy="594360"/>
+          </a:xfrm>
+          <a:prstGeom prst="roundRect">
+            <a:avLst/>
+          </a:prstGeom>
+          <a:solidFill>
+            <a:srgbClr val="C7E0F4"/>
+          </a:solidFill>
+          <a:ln w="15240">
+            <a:solidFill>
+              <a:srgbClr val="6495ED"/>
+            </a:solidFill>
+          </a:ln>
+        </p:spPr>
+        <p:style>
+          <a:lnRef idx="1">
+            <a:schemeClr val="accent1"/>
+          </a:lnRef>
+          <a:fillRef idx="3">
+            <a:schemeClr val="accent1"/>
+          </a:fillRef>
+          <a:effectRef idx="2">
+            <a:schemeClr val="accent1"/>
+          </a:effectRef>
+          <a:fontRef idx="minor">
+            <a:schemeClr val="lt1"/>
+          </a:fontRef>
+        </p:style>
+        <p:txBody>
+          <a:bodyPr rtlCol="0" anchor="ctr" wrap="square"/>
+          <a:lstStyle/>
+          <a:p>
+            <a:pPr algn="ctr">
+              <a:defRPr sz="850" b="1">
+                <a:solidFill>
+                  <a:srgbClr val="1E293B"/>
+                </a:solidFill>
+                <a:latin typeface="Arial"/>
+              </a:defRPr>
+            </a:pPr>
+            <a:r>
+              <a:t>Investigator</a:t>
+            </a:r>
+            <a:br/>
+            <a:r>
+              <a:t>/ Officer</a:t>
+            </a:r>
+          </a:p>
+        </p:txBody>
+      </p:sp>
+      <p:sp>
+        <p:nvSpPr>
+          <p:cNvPr id="6" name="Rectangle 5"/>
+          <p:cNvSpPr/>
+          <p:nvPr/>
+        </p:nvSpPr>
+        <p:spPr>
+          <a:xfrm>
+            <a:off x="1691640" y="2011680"/>
+            <a:ext cx="960120" cy="502920"/>
+          </a:xfrm>
+          <a:prstGeom prst="rect">
+            <a:avLst/>
+          </a:prstGeom>
+          <a:solidFill>
+            <a:srgbClr val="8C8C8C"/>
+          </a:solidFill>
+          <a:ln w="15240">
+            <a:solidFill>
+              <a:srgbClr val="8C8C8C"/>
+            </a:solidFill>
+          </a:ln>
+        </p:spPr>
+        <p:style>
+          <a:lnRef idx="1">
+            <a:schemeClr val="accent1"/>
+          </a:lnRef>
+          <a:fillRef idx="3">
+            <a:schemeClr val="accent1"/>
+          </a:fillRef>
+          <a:effectRef idx="2">
+            <a:schemeClr val="accent1"/>
+          </a:effectRef>
+          <a:fontRef idx="minor">
+            <a:schemeClr val="lt1"/>
+          </a:fontRef>
+        </p:style>
+        <p:txBody>
+          <a:bodyPr rtlCol="0" anchor="ctr" wrap="square"/>
+          <a:lstStyle/>
+          <a:p>
+            <a:pPr algn="ctr">
+              <a:defRPr sz="800" b="1">
+                <a:solidFill>
+                  <a:srgbClr val="FFFFFF"/>
+                </a:solidFill>
+                <a:latin typeface="Arial"/>
+              </a:defRPr>
+            </a:pPr>
+            <a:r>
+              <a:t>Evidence</a:t>
+            </a:r>
+            <a:br/>
+            <a:r>
+              <a:t>Upload</a:t>
+            </a:r>
+          </a:p>
+        </p:txBody>
+      </p:sp>
+      <p:sp>
+        <p:nvSpPr>
+          <p:cNvPr id="7" name="Rectangle 6"/>
+          <p:cNvSpPr/>
+          <p:nvPr/>
+        </p:nvSpPr>
+        <p:spPr>
+          <a:xfrm>
+            <a:off x="1691640" y="4434840"/>
+            <a:ext cx="960120" cy="502920"/>
+          </a:xfrm>
+          <a:prstGeom prst="rect">
+            <a:avLst/>
+          </a:prstGeom>
+          <a:solidFill>
+            <a:srgbClr val="8C8C8C"/>
+          </a:solidFill>
+          <a:ln w="15240">
+            <a:solidFill>
+              <a:srgbClr val="8C8C8C"/>
+            </a:solidFill>
+          </a:ln>
+        </p:spPr>
+        <p:style>
+          <a:lnRef idx="1">
+            <a:schemeClr val="accent1"/>
+          </a:lnRef>
+          <a:fillRef idx="3">
+            <a:schemeClr val="accent1"/>
+          </a:fillRef>
+          <a:effectRef idx="2">
+            <a:schemeClr val="accent1"/>
+          </a:effectRef>
+          <a:fontRef idx="minor">
+            <a:schemeClr val="lt1"/>
+          </a:fontRef>
+        </p:style>
+        <p:txBody>
+          <a:bodyPr rtlCol="0" anchor="ctr" wrap="square"/>
+          <a:lstStyle/>
+          <a:p>
+            <a:pPr algn="ctr">
+              <a:defRPr sz="800" b="1">
+                <a:solidFill>
+                  <a:srgbClr val="FFFFFF"/>
+                </a:solidFill>
+                <a:latin typeface="Arial"/>
+              </a:defRPr>
+            </a:pPr>
+            <a:r>
+              <a:t>FIR Direct</a:t>
+            </a:r>
+            <a:br/>
+            <a:r>
+              <a:t>Paste</a:t>
+            </a:r>
+          </a:p>
+        </p:txBody>
+      </p:sp>
+      <p:cxnSp>
+        <p:nvCxnSpPr>
+          <p:cNvPr id="8" name="Connector 7"/>
+          <p:cNvCxnSpPr/>
+          <p:nvPr/>
+        </p:nvCxnSpPr>
+        <p:spPr>
+          <a:xfrm flipV="1">
+            <a:off x="1325880" y="2263140"/>
+            <a:ext cx="365760" cy="1280160"/>
+          </a:xfrm>
+          <a:prstGeom prst="line">
+            <a:avLst/>
+          </a:prstGeom>
+          <a:ln w="15240">
+            <a:solidFill>
+              <a:srgbClr val="5A6978"/>
+            </a:solidFill>
+          </a:ln>
+        </p:spPr>
+        <p:style>
+          <a:lnRef idx="2">
+            <a:schemeClr val="accent1"/>
+          </a:lnRef>
+          <a:fillRef idx="0">
+            <a:schemeClr val="accent1"/>
+          </a:fillRef>
+          <a:effectRef idx="1">
+            <a:schemeClr val="accent1"/>
+          </a:effectRef>
+          <a:fontRef idx="minor">
+            <a:schemeClr val="tx1"/>
+          </a:fontRef>
+        </p:style>
+      </p:cxnSp>
+      <p:cxnSp>
+        <p:nvCxnSpPr>
+          <p:cNvPr id="9" name="Connector 8"/>
+          <p:cNvCxnSpPr/>
+          <p:nvPr/>
+        </p:nvCxnSpPr>
+        <p:spPr>
+          <a:xfrm>
+            <a:off x="1325880" y="3543300"/>
+            <a:ext cx="365760" cy="1143000"/>
+          </a:xfrm>
+          <a:prstGeom prst="line">
+            <a:avLst/>
+          </a:prstGeom>
+          <a:ln w="15240">
+            <a:solidFill>
+              <a:srgbClr val="5A6978"/>
+            </a:solidFill>
+          </a:ln>
+        </p:spPr>
+        <p:style>
+          <a:lnRef idx="2">
+            <a:schemeClr val="accent1"/>
+          </a:lnRef>
+          <a:fillRef idx="0">
+            <a:schemeClr val="accent1"/>
+          </a:fillRef>
+          <a:effectRef idx="1">
+            <a:schemeClr val="accent1"/>
+          </a:effectRef>
+          <a:fontRef idx="minor">
+            <a:schemeClr val="tx1"/>
+          </a:fontRef>
+        </p:style>
+      </p:cxnSp>
+      <p:sp>
+        <p:nvSpPr>
+          <p:cNvPr id="10" name="Rounded Rectangle 9"/>
+          <p:cNvSpPr/>
+          <p:nvPr/>
+        </p:nvSpPr>
+        <p:spPr>
+          <a:xfrm>
+            <a:off x="2880360" y="2011680"/>
+            <a:ext cx="777240" cy="411480"/>
+          </a:xfrm>
+          <a:prstGeom prst="roundRect">
+            <a:avLst/>
+          </a:prstGeom>
+          <a:solidFill>
+            <a:srgbClr val="99E6F2"/>
+          </a:solidFill>
+          <a:ln w="15240">
+            <a:solidFill>
+              <a:srgbClr val="00A0BE"/>
+            </a:solidFill>
+          </a:ln>
+        </p:spPr>
+        <p:style>
+          <a:lnRef idx="1">
+            <a:schemeClr val="accent1"/>
+          </a:lnRef>
+          <a:fillRef idx="3">
+            <a:schemeClr val="accent1"/>
+          </a:fillRef>
+          <a:effectRef idx="2">
+            <a:schemeClr val="accent1"/>
+          </a:effectRef>
+          <a:fontRef idx="minor">
+            <a:schemeClr val="lt1"/>
+          </a:fontRef>
+        </p:style>
+        <p:txBody>
+          <a:bodyPr rtlCol="0" anchor="ctr" wrap="square"/>
+          <a:lstStyle/>
+          <a:p>
+            <a:pPr algn="ctr">
+              <a:defRPr sz="800" b="1">
+                <a:solidFill>
+                  <a:srgbClr val="1E293B"/>
+                </a:solidFill>
+                <a:latin typeface="Arial"/>
+              </a:defRPr>
+            </a:pPr>
+            <a:r>
+              <a:t>Authenticate</a:t>
+            </a:r>
+          </a:p>
+        </p:txBody>
+      </p:sp>
+      <p:sp>
+        <p:nvSpPr>
+          <p:cNvPr id="11" name="Rounded Rectangle 10"/>
+          <p:cNvSpPr/>
+          <p:nvPr/>
+        </p:nvSpPr>
+        <p:spPr>
+          <a:xfrm>
+            <a:off x="2880360" y="4434840"/>
+            <a:ext cx="777240" cy="411480"/>
+          </a:xfrm>
+          <a:prstGeom prst="roundRect">
+            <a:avLst/>
+          </a:prstGeom>
+          <a:solidFill>
+            <a:srgbClr val="99E6F2"/>
+          </a:solidFill>
+          <a:ln w="15240">
+            <a:solidFill>
+              <a:srgbClr val="00A0BE"/>
+            </a:solidFill>
+          </a:ln>
+        </p:spPr>
+        <p:style>
+          <a:lnRef idx="1">
+            <a:schemeClr val="accent1"/>
+          </a:lnRef>
+          <a:fillRef idx="3">
+            <a:schemeClr val="accent1"/>
+          </a:fillRef>
+          <a:effectRef idx="2">
+            <a:schemeClr val="accent1"/>
+          </a:effectRef>
+          <a:fontRef idx="minor">
+            <a:schemeClr val="lt1"/>
+          </a:fontRef>
+        </p:style>
+        <p:txBody>
+          <a:bodyPr rtlCol="0" anchor="ctr" wrap="square"/>
+          <a:lstStyle/>
+          <a:p>
+            <a:pPr algn="ctr">
+              <a:defRPr sz="800" b="1">
+                <a:solidFill>
+                  <a:srgbClr val="1E293B"/>
+                </a:solidFill>
+                <a:latin typeface="Arial"/>
+              </a:defRPr>
+            </a:pPr>
+            <a:r>
+              <a:t>Case Intake</a:t>
+            </a:r>
+          </a:p>
+        </p:txBody>
+      </p:sp>
+      <p:cxnSp>
+        <p:nvCxnSpPr>
+          <p:cNvPr id="12" name="Connector 11"/>
+          <p:cNvCxnSpPr/>
+          <p:nvPr/>
+        </p:nvCxnSpPr>
+        <p:spPr>
+          <a:xfrm flipV="1">
+            <a:off x="2651760" y="2217420"/>
+            <a:ext cx="228600" cy="45720"/>
+          </a:xfrm>
+          <a:prstGeom prst="line">
+            <a:avLst/>
+          </a:prstGeom>
+          <a:ln w="15240">
+            <a:solidFill>
+              <a:srgbClr val="5A6978"/>
+            </a:solidFill>
+          </a:ln>
+        </p:spPr>
+        <p:style>
+          <a:lnRef idx="2">
+            <a:schemeClr val="accent1"/>
+          </a:lnRef>
+          <a:fillRef idx="0">
+            <a:schemeClr val="accent1"/>
+          </a:fillRef>
+          <a:effectRef idx="1">
+            <a:schemeClr val="accent1"/>
+          </a:effectRef>
+          <a:fontRef idx="minor">
+            <a:schemeClr val="tx1"/>
+          </a:fontRef>
+        </p:style>
+      </p:cxnSp>
+      <p:cxnSp>
+        <p:nvCxnSpPr>
+          <p:cNvPr id="13" name="Connector 12"/>
+          <p:cNvCxnSpPr/>
+          <p:nvPr/>
+        </p:nvCxnSpPr>
+        <p:spPr>
+          <a:xfrm flipV="1">
+            <a:off x="2651760" y="4640580"/>
+            <a:ext cx="228600" cy="45720"/>
+          </a:xfrm>
+          <a:prstGeom prst="line">
+            <a:avLst/>
+          </a:prstGeom>
+          <a:ln w="15240">
+            <a:solidFill>
+              <a:srgbClr val="5A6978"/>
+            </a:solidFill>
+          </a:ln>
+        </p:spPr>
+        <p:style>
+          <a:lnRef idx="2">
+            <a:schemeClr val="accent1"/>
+          </a:lnRef>
+          <a:fillRef idx="0">
+            <a:schemeClr val="accent1"/>
+          </a:fillRef>
+          <a:effectRef idx="1">
+            <a:schemeClr val="accent1"/>
+          </a:effectRef>
+          <a:fontRef idx="minor">
+            <a:schemeClr val="tx1"/>
+          </a:fontRef>
+        </p:style>
+      </p:cxnSp>
+      <p:sp>
+        <p:nvSpPr>
+          <p:cNvPr id="14" name="Diamond 13"/>
+          <p:cNvSpPr/>
+          <p:nvPr/>
+        </p:nvSpPr>
+        <p:spPr>
+          <a:xfrm>
+            <a:off x="3840480" y="1874519"/>
+            <a:ext cx="868680" cy="685800"/>
+          </a:xfrm>
+          <a:prstGeom prst="diamond">
+            <a:avLst/>
+          </a:prstGeom>
+          <a:solidFill>
+            <a:srgbClr val="99E6F2"/>
+          </a:solidFill>
+          <a:ln w="15240">
+            <a:solidFill>
+              <a:srgbClr val="00A0BE"/>
+            </a:solidFill>
+          </a:ln>
+        </p:spPr>
+        <p:style>
+          <a:lnRef idx="1">
+            <a:schemeClr val="accent1"/>
+          </a:lnRef>
+          <a:fillRef idx="3">
+            <a:schemeClr val="accent1"/>
+          </a:fillRef>
+          <a:effectRef idx="2">
+            <a:schemeClr val="accent1"/>
+          </a:effectRef>
+          <a:fontRef idx="minor">
+            <a:schemeClr val="lt1"/>
+          </a:fontRef>
+        </p:style>
+        <p:txBody>
+          <a:bodyPr rtlCol="0" anchor="ctr" wrap="square"/>
+          <a:lstStyle/>
+          <a:p>
+            <a:pPr algn="ctr">
+              <a:defRPr sz="750" b="1">
+                <a:solidFill>
+                  <a:srgbClr val="1E293B"/>
+                </a:solidFill>
+                <a:latin typeface="Arial"/>
+              </a:defRPr>
+            </a:pPr>
+            <a:r>
+              <a:t>Case</a:t>
+            </a:r>
+            <a:br/>
+            <a:r>
+              <a:t>Exists?</a:t>
+            </a:r>
+          </a:p>
+        </p:txBody>
+      </p:sp>
+      <p:sp>
+        <p:nvSpPr>
+          <p:cNvPr id="15" name="Diamond 14"/>
+          <p:cNvSpPr/>
+          <p:nvPr/>
+        </p:nvSpPr>
+        <p:spPr>
+          <a:xfrm>
+            <a:off x="3840480" y="4297680"/>
+            <a:ext cx="868680" cy="685800"/>
+          </a:xfrm>
+          <a:prstGeom prst="diamond">
+            <a:avLst/>
+          </a:prstGeom>
+          <a:solidFill>
+            <a:srgbClr val="99E6F2"/>
+          </a:solidFill>
+          <a:ln w="15240">
+            <a:solidFill>
+              <a:srgbClr val="00A0BE"/>
+            </a:solidFill>
+          </a:ln>
+        </p:spPr>
+        <p:style>
+          <a:lnRef idx="1">
+            <a:schemeClr val="accent1"/>
+          </a:lnRef>
+          <a:fillRef idx="3">
+            <a:schemeClr val="accent1"/>
+          </a:fillRef>
+          <a:effectRef idx="2">
+            <a:schemeClr val="accent1"/>
+          </a:effectRef>
+          <a:fontRef idx="minor">
+            <a:schemeClr val="lt1"/>
+          </a:fontRef>
+        </p:style>
+        <p:txBody>
+          <a:bodyPr rtlCol="0" anchor="ctr" wrap="square"/>
+          <a:lstStyle/>
+          <a:p>
+            <a:pPr algn="ctr">
+              <a:defRPr sz="750" b="1">
+                <a:solidFill>
+                  <a:srgbClr val="1E293B"/>
+                </a:solidFill>
+                <a:latin typeface="Arial"/>
+              </a:defRPr>
+            </a:pPr>
+            <a:r>
+              <a:t>Valid</a:t>
+            </a:r>
+            <a:br/>
+            <a:r>
+              <a:t>Format?</a:t>
+            </a:r>
+          </a:p>
+        </p:txBody>
+      </p:sp>
+      <p:cxnSp>
+        <p:nvCxnSpPr>
+          <p:cNvPr id="16" name="Connector 15"/>
+          <p:cNvCxnSpPr/>
+          <p:nvPr/>
+        </p:nvCxnSpPr>
+        <p:spPr>
+          <a:xfrm>
+            <a:off x="3657600" y="2217420"/>
+            <a:ext cx="182880" cy="0"/>
+          </a:xfrm>
+          <a:prstGeom prst="line">
+            <a:avLst/>
+          </a:prstGeom>
+          <a:ln w="15240">
+            <a:solidFill>
+              <a:srgbClr val="5A6978"/>
+            </a:solidFill>
+          </a:ln>
+        </p:spPr>
+        <p:style>
+          <a:lnRef idx="2">
+            <a:schemeClr val="accent1"/>
+          </a:lnRef>
+          <a:fillRef idx="0">
+            <a:schemeClr val="accent1"/>
+          </a:fillRef>
+          <a:effectRef idx="1">
+            <a:schemeClr val="accent1"/>
+          </a:effectRef>
+          <a:fontRef idx="minor">
+            <a:schemeClr val="tx1"/>
+          </a:fontRef>
+        </p:style>
+      </p:cxnSp>
+      <p:cxnSp>
+        <p:nvCxnSpPr>
+          <p:cNvPr id="17" name="Connector 16"/>
+          <p:cNvCxnSpPr/>
+          <p:nvPr/>
+        </p:nvCxnSpPr>
+        <p:spPr>
+          <a:xfrm>
+            <a:off x="3657600" y="4640580"/>
+            <a:ext cx="182880" cy="0"/>
+          </a:xfrm>
+          <a:prstGeom prst="line">
+            <a:avLst/>
+          </a:prstGeom>
+          <a:ln w="15240">
+            <a:solidFill>
+              <a:srgbClr val="5A6978"/>
+            </a:solidFill>
+          </a:ln>
+        </p:spPr>
+        <p:style>
+          <a:lnRef idx="2">
+            <a:schemeClr val="accent1"/>
+          </a:lnRef>
+          <a:fillRef idx="0">
+            <a:schemeClr val="accent1"/>
+          </a:fillRef>
+          <a:effectRef idx="1">
+            <a:schemeClr val="accent1"/>
+          </a:effectRef>
+          <a:fontRef idx="minor">
+            <a:schemeClr val="tx1"/>
+          </a:fontRef>
+        </p:style>
+      </p:cxnSp>
+      <p:sp>
+        <p:nvSpPr>
+          <p:cNvPr id="18" name="Rounded Rectangle 17"/>
+          <p:cNvSpPr/>
+          <p:nvPr/>
+        </p:nvSpPr>
+        <p:spPr>
+          <a:xfrm>
+            <a:off x="3657600" y="3154680"/>
+            <a:ext cx="1234440" cy="502920"/>
+          </a:xfrm>
+          <a:prstGeom prst="roundRect">
+            <a:avLst/>
+          </a:prstGeom>
+          <a:solidFill>
+            <a:srgbClr val="8C8C8C"/>
+          </a:solidFill>
+          <a:ln w="15240">
+            <a:solidFill>
+              <a:srgbClr val="8C8C8C"/>
+            </a:solidFill>
+          </a:ln>
+        </p:spPr>
+        <p:style>
+          <a:lnRef idx="1">
+            <a:schemeClr val="accent1"/>
+          </a:lnRef>
+          <a:fillRef idx="3">
+            <a:schemeClr val="accent1"/>
+          </a:fillRef>
+          <a:effectRef idx="2">
+            <a:schemeClr val="accent1"/>
+          </a:effectRef>
+          <a:fontRef idx="minor">
+            <a:schemeClr val="lt1"/>
+          </a:fontRef>
+        </p:style>
+        <p:txBody>
+          <a:bodyPr rtlCol="0" anchor="ctr" wrap="square"/>
+          <a:lstStyle/>
+          <a:p>
+            <a:pPr algn="ctr">
+              <a:defRPr sz="750" b="1">
+                <a:solidFill>
+                  <a:srgbClr val="FFFFFF"/>
+                </a:solidFill>
+                <a:latin typeface="Arial"/>
+              </a:defRPr>
+            </a:pPr>
+            <a:r>
+              <a:t>Create Case &amp;</a:t>
+            </a:r>
+            <a:br/>
+            <a:r>
+              <a:t>Init SQLite Vault</a:t>
+            </a:r>
+          </a:p>
+        </p:txBody>
+      </p:sp>
+      <p:cxnSp>
+        <p:nvCxnSpPr>
+          <p:cNvPr id="19" name="Connector 18"/>
+          <p:cNvCxnSpPr/>
+          <p:nvPr/>
+        </p:nvCxnSpPr>
+        <p:spPr>
+          <a:xfrm>
+            <a:off x="4274820" y="2560320"/>
+            <a:ext cx="0" cy="594360"/>
+          </a:xfrm>
+          <a:prstGeom prst="line">
+            <a:avLst/>
+          </a:prstGeom>
+          <a:ln w="15240">
+            <a:solidFill>
+              <a:srgbClr val="5A6978"/>
+            </a:solidFill>
+          </a:ln>
+        </p:spPr>
+        <p:style>
+          <a:lnRef idx="2">
+            <a:schemeClr val="accent1"/>
+          </a:lnRef>
+          <a:fillRef idx="0">
+            <a:schemeClr val="accent1"/>
+          </a:fillRef>
+          <a:effectRef idx="1">
+            <a:schemeClr val="accent1"/>
+          </a:effectRef>
+          <a:fontRef idx="minor">
+            <a:schemeClr val="tx1"/>
+          </a:fontRef>
+        </p:style>
+      </p:cxnSp>
+      <p:cxnSp>
+        <p:nvCxnSpPr>
+          <p:cNvPr id="20" name="Connector 19"/>
+          <p:cNvCxnSpPr/>
+          <p:nvPr/>
+        </p:nvCxnSpPr>
+        <p:spPr>
+          <a:xfrm flipV="1">
+            <a:off x="4274820" y="3657600"/>
+            <a:ext cx="0" cy="640080"/>
+          </a:xfrm>
+          <a:prstGeom prst="line">
+            <a:avLst/>
+          </a:prstGeom>
+          <a:ln w="15240">
+            <a:solidFill>
+              <a:srgbClr val="5A6978"/>
+            </a:solidFill>
+          </a:ln>
+        </p:spPr>
+        <p:style>
+          <a:lnRef idx="2">
+            <a:schemeClr val="accent1"/>
+          </a:lnRef>
+          <a:fillRef idx="0">
+            <a:schemeClr val="accent1"/>
+          </a:fillRef>
+          <a:effectRef idx="1">
+            <a:schemeClr val="accent1"/>
+          </a:effectRef>
+          <a:fontRef idx="minor">
+            <a:schemeClr val="tx1"/>
+          </a:fontRef>
+        </p:style>
+      </p:cxnSp>
+      <p:cxnSp>
+        <p:nvCxnSpPr>
+          <p:cNvPr id="21" name="Connector 20"/>
+          <p:cNvCxnSpPr/>
+          <p:nvPr/>
+        </p:nvCxnSpPr>
+        <p:spPr>
+          <a:xfrm>
+            <a:off x="4709160" y="2217420"/>
+            <a:ext cx="274320" cy="0"/>
+          </a:xfrm>
+          <a:prstGeom prst="line">
+            <a:avLst/>
+          </a:prstGeom>
+          <a:ln w="15240">
+            <a:solidFill>
+              <a:srgbClr val="5A6978"/>
+            </a:solidFill>
+          </a:ln>
+        </p:spPr>
+        <p:style>
+          <a:lnRef idx="2">
+            <a:schemeClr val="accent1"/>
+          </a:lnRef>
+          <a:fillRef idx="0">
+            <a:schemeClr val="accent1"/>
+          </a:fillRef>
+          <a:effectRef idx="1">
+            <a:schemeClr val="accent1"/>
+          </a:effectRef>
+          <a:fontRef idx="minor">
+            <a:schemeClr val="tx1"/>
+          </a:fontRef>
+        </p:style>
+      </p:cxnSp>
+      <p:cxnSp>
+        <p:nvCxnSpPr>
+          <p:cNvPr id="22" name="Connector 21"/>
+          <p:cNvCxnSpPr/>
+          <p:nvPr/>
+        </p:nvCxnSpPr>
+        <p:spPr>
+          <a:xfrm>
+            <a:off x="4709160" y="4640580"/>
+            <a:ext cx="274320" cy="0"/>
+          </a:xfrm>
+          <a:prstGeom prst="line">
+            <a:avLst/>
+          </a:prstGeom>
+          <a:ln w="15240">
+            <a:solidFill>
+              <a:srgbClr val="5A6978"/>
+            </a:solidFill>
+          </a:ln>
+        </p:spPr>
+        <p:style>
+          <a:lnRef idx="2">
+            <a:schemeClr val="accent1"/>
+          </a:lnRef>
+          <a:fillRef idx="0">
+            <a:schemeClr val="accent1"/>
+          </a:fillRef>
+          <a:effectRef idx="1">
+            <a:schemeClr val="accent1"/>
+          </a:effectRef>
+          <a:fontRef idx="minor">
+            <a:schemeClr val="tx1"/>
+          </a:fontRef>
+        </p:style>
+      </p:cxnSp>
+      <p:cxnSp>
+        <p:nvCxnSpPr>
+          <p:cNvPr id="23" name="Connector 22"/>
+          <p:cNvCxnSpPr/>
+          <p:nvPr/>
+        </p:nvCxnSpPr>
+        <p:spPr>
+          <a:xfrm>
+            <a:off x="4983480" y="1280160"/>
+            <a:ext cx="0" cy="4663440"/>
+          </a:xfrm>
+          <a:prstGeom prst="line">
+            <a:avLst/>
+          </a:prstGeom>
+          <a:ln w="15240">
+            <a:solidFill>
+              <a:srgbClr val="5A6978"/>
+            </a:solidFill>
+          </a:ln>
+        </p:spPr>
+        <p:style>
+          <a:lnRef idx="2">
+            <a:schemeClr val="accent1"/>
+          </a:lnRef>
+          <a:fillRef idx="0">
+            <a:schemeClr val="accent1"/>
+          </a:fillRef>
+          <a:effectRef idx="1">
+            <a:schemeClr val="accent1"/>
+          </a:effectRef>
+          <a:fontRef idx="minor">
+            <a:schemeClr val="tx1"/>
+          </a:fontRef>
+        </p:style>
+      </p:cxnSp>
+      <p:cxnSp>
+        <p:nvCxnSpPr>
+          <p:cNvPr id="24" name="Connector 23"/>
+          <p:cNvCxnSpPr/>
+          <p:nvPr/>
+        </p:nvCxnSpPr>
+        <p:spPr>
+          <a:xfrm>
+            <a:off x="4983480" y="1435608"/>
+            <a:ext cx="137160" cy="0"/>
+          </a:xfrm>
+          <a:prstGeom prst="line">
+            <a:avLst/>
+          </a:prstGeom>
+          <a:ln w="15240">
+            <a:solidFill>
+              <a:srgbClr val="5A6978"/>
+            </a:solidFill>
+          </a:ln>
+        </p:spPr>
+        <p:style>
+          <a:lnRef idx="2">
+            <a:schemeClr val="accent1"/>
+          </a:lnRef>
+          <a:fillRef idx="0">
+            <a:schemeClr val="accent1"/>
+          </a:fillRef>
+          <a:effectRef idx="1">
+            <a:schemeClr val="accent1"/>
+          </a:effectRef>
+          <a:fontRef idx="minor">
+            <a:schemeClr val="tx1"/>
+          </a:fontRef>
+        </p:style>
+      </p:cxnSp>
+      <p:sp>
+        <p:nvSpPr>
+          <p:cNvPr id="25" name="Rectangle 24"/>
+          <p:cNvSpPr/>
+          <p:nvPr/>
+        </p:nvSpPr>
+        <p:spPr>
+          <a:xfrm>
+            <a:off x="5120640" y="1234440"/>
+            <a:ext cx="960120" cy="402336"/>
+          </a:xfrm>
+          <a:prstGeom prst="rect">
+            <a:avLst/>
+          </a:prstGeom>
+          <a:solidFill>
+            <a:srgbClr val="FEEBA9"/>
+          </a:solidFill>
+          <a:ln w="15240">
+            <a:solidFill>
+              <a:srgbClr val="DAAF37"/>
+            </a:solidFill>
+          </a:ln>
+        </p:spPr>
+        <p:style>
+          <a:lnRef idx="1">
+            <a:schemeClr val="accent1"/>
+          </a:lnRef>
+          <a:fillRef idx="3">
+            <a:schemeClr val="accent1"/>
+          </a:fillRef>
+          <a:effectRef idx="2">
+            <a:schemeClr val="accent1"/>
+          </a:effectRef>
+          <a:fontRef idx="minor">
+            <a:schemeClr val="lt1"/>
+          </a:fontRef>
+        </p:style>
+        <p:txBody>
+          <a:bodyPr rtlCol="0" anchor="ctr" wrap="square"/>
+          <a:lstStyle/>
+          <a:p>
+            <a:pPr algn="ctr">
+              <a:defRPr sz="750" b="1">
+                <a:solidFill>
+                  <a:srgbClr val="1E293B"/>
+                </a:solidFill>
+                <a:latin typeface="Arial"/>
+              </a:defRPr>
+            </a:pPr>
+            <a:r>
+              <a:t>Universal ETL</a:t>
+            </a:r>
+          </a:p>
+        </p:txBody>
+      </p:sp>
+      <p:sp>
+        <p:nvSpPr>
+          <p:cNvPr id="26" name="Rounded Rectangle 25"/>
+          <p:cNvSpPr/>
+          <p:nvPr/>
+        </p:nvSpPr>
+        <p:spPr>
+          <a:xfrm>
+            <a:off x="6245352" y="1234440"/>
+            <a:ext cx="1005840" cy="402336"/>
+          </a:xfrm>
+          <a:prstGeom prst="roundRect">
+            <a:avLst/>
+          </a:prstGeom>
+          <a:solidFill>
+            <a:srgbClr val="C8F5A0"/>
+          </a:solidFill>
+          <a:ln w="15240">
+            <a:solidFill>
+              <a:srgbClr val="64B43C"/>
+            </a:solidFill>
+          </a:ln>
+        </p:spPr>
+        <p:style>
+          <a:lnRef idx="1">
+            <a:schemeClr val="accent1"/>
+          </a:lnRef>
+          <a:fillRef idx="3">
+            <a:schemeClr val="accent1"/>
+          </a:fillRef>
+          <a:effectRef idx="2">
+            <a:schemeClr val="accent1"/>
+          </a:effectRef>
+          <a:fontRef idx="minor">
+            <a:schemeClr val="lt1"/>
+          </a:fontRef>
+        </p:style>
+        <p:txBody>
+          <a:bodyPr rtlCol="0" anchor="ctr" wrap="square"/>
+          <a:lstStyle/>
+          <a:p>
+            <a:pPr algn="ctr">
+              <a:defRPr sz="750" b="1">
+                <a:solidFill>
+                  <a:srgbClr val="1E293B"/>
+                </a:solidFill>
+                <a:latin typeface="Arial"/>
+              </a:defRPr>
+            </a:pPr>
+            <a:r>
+              <a:t>OCRNormalizer</a:t>
+            </a:r>
+          </a:p>
+        </p:txBody>
+      </p:sp>
+      <p:cxnSp>
+        <p:nvCxnSpPr>
+          <p:cNvPr id="27" name="Connector 26"/>
+          <p:cNvCxnSpPr/>
+          <p:nvPr/>
+        </p:nvCxnSpPr>
+        <p:spPr>
+          <a:xfrm>
+            <a:off x="6080760" y="1435608"/>
+            <a:ext cx="164592" cy="0"/>
+          </a:xfrm>
+          <a:prstGeom prst="line">
+            <a:avLst/>
+          </a:prstGeom>
+          <a:ln w="15240">
+            <a:solidFill>
+              <a:srgbClr val="5A6978"/>
+            </a:solidFill>
+          </a:ln>
+        </p:spPr>
+        <p:style>
+          <a:lnRef idx="2">
+            <a:schemeClr val="accent1"/>
+          </a:lnRef>
+          <a:fillRef idx="0">
+            <a:schemeClr val="accent1"/>
+          </a:fillRef>
+          <a:effectRef idx="1">
+            <a:schemeClr val="accent1"/>
+          </a:effectRef>
+          <a:fontRef idx="minor">
+            <a:schemeClr val="tx1"/>
+          </a:fontRef>
+        </p:style>
+      </p:cxnSp>
+      <p:sp>
+        <p:nvSpPr>
+          <p:cNvPr id="28" name="Rounded Rectangle 27"/>
+          <p:cNvSpPr/>
+          <p:nvPr/>
+        </p:nvSpPr>
+        <p:spPr>
+          <a:xfrm>
+            <a:off x="7415784" y="1234440"/>
+            <a:ext cx="1143000" cy="402336"/>
+          </a:xfrm>
+          <a:prstGeom prst="roundRect">
+            <a:avLst/>
+          </a:prstGeom>
+          <a:solidFill>
+            <a:srgbClr val="99E6F2"/>
+          </a:solidFill>
+          <a:ln w="15240">
+            <a:solidFill>
+              <a:srgbClr val="00A0BE"/>
+            </a:solidFill>
+          </a:ln>
+        </p:spPr>
+        <p:style>
+          <a:lnRef idx="1">
+            <a:schemeClr val="accent1"/>
+          </a:lnRef>
+          <a:fillRef idx="3">
+            <a:schemeClr val="accent1"/>
+          </a:fillRef>
+          <a:effectRef idx="2">
+            <a:schemeClr val="accent1"/>
+          </a:effectRef>
+          <a:fontRef idx="minor">
+            <a:schemeClr val="lt1"/>
+          </a:fontRef>
+        </p:style>
+        <p:txBody>
+          <a:bodyPr rtlCol="0" anchor="ctr" wrap="square"/>
+          <a:lstStyle/>
+          <a:p>
+            <a:pPr algn="ctr">
+              <a:defRPr sz="750" b="1">
+                <a:solidFill>
+                  <a:srgbClr val="1E293B"/>
+                </a:solidFill>
+                <a:latin typeface="Arial"/>
+              </a:defRPr>
+            </a:pPr>
+            <a:r>
+              <a:t>SHA-256 Provenance</a:t>
+            </a:r>
+          </a:p>
+        </p:txBody>
+      </p:sp>
+      <p:cxnSp>
+        <p:nvCxnSpPr>
+          <p:cNvPr id="29" name="Connector 28"/>
+          <p:cNvCxnSpPr/>
+          <p:nvPr/>
+        </p:nvCxnSpPr>
+        <p:spPr>
+          <a:xfrm>
+            <a:off x="7251192" y="1435608"/>
+            <a:ext cx="164592" cy="0"/>
+          </a:xfrm>
+          <a:prstGeom prst="line">
+            <a:avLst/>
+          </a:prstGeom>
+          <a:ln w="15240">
+            <a:solidFill>
+              <a:srgbClr val="5A6978"/>
+            </a:solidFill>
+          </a:ln>
+        </p:spPr>
+        <p:style>
+          <a:lnRef idx="2">
+            <a:schemeClr val="accent1"/>
+          </a:lnRef>
+          <a:fillRef idx="0">
+            <a:schemeClr val="accent1"/>
+          </a:fillRef>
+          <a:effectRef idx="1">
+            <a:schemeClr val="accent1"/>
+          </a:effectRef>
+          <a:fontRef idx="minor">
+            <a:schemeClr val="tx1"/>
+          </a:fontRef>
+        </p:style>
+      </p:cxnSp>
+      <p:sp>
+        <p:nvSpPr>
+          <p:cNvPr id="30" name="Rounded Rectangle 29"/>
+          <p:cNvSpPr/>
+          <p:nvPr/>
+        </p:nvSpPr>
+        <p:spPr>
+          <a:xfrm>
+            <a:off x="8723376" y="1234440"/>
+            <a:ext cx="960120" cy="402336"/>
+          </a:xfrm>
+          <a:prstGeom prst="roundRect">
+            <a:avLst/>
+          </a:prstGeom>
+          <a:solidFill>
+            <a:srgbClr val="C8AFE1"/>
+          </a:solidFill>
+          <a:ln w="15240">
+            <a:solidFill>
+              <a:srgbClr val="8C64B4"/>
+            </a:solidFill>
+          </a:ln>
+        </p:spPr>
+        <p:style>
+          <a:lnRef idx="1">
+            <a:schemeClr val="accent1"/>
+          </a:lnRef>
+          <a:fillRef idx="3">
+            <a:schemeClr val="accent1"/>
+          </a:fillRef>
+          <a:effectRef idx="2">
+            <a:schemeClr val="accent1"/>
+          </a:effectRef>
+          <a:fontRef idx="minor">
+            <a:schemeClr val="lt1"/>
+          </a:fontRef>
+        </p:style>
+        <p:txBody>
+          <a:bodyPr rtlCol="0" anchor="ctr" wrap="square"/>
+          <a:lstStyle/>
+          <a:p>
+            <a:pPr algn="ctr">
+              <a:defRPr sz="750" b="1">
+                <a:solidFill>
+                  <a:srgbClr val="1E293B"/>
+                </a:solidFill>
+                <a:latin typeface="Arial"/>
+              </a:defRPr>
+            </a:pPr>
+            <a:r>
+              <a:t>Encrypted Vault</a:t>
+            </a:r>
+          </a:p>
+        </p:txBody>
+      </p:sp>
+      <p:cxnSp>
+        <p:nvCxnSpPr>
+          <p:cNvPr id="31" name="Connector 30"/>
+          <p:cNvCxnSpPr/>
+          <p:nvPr/>
+        </p:nvCxnSpPr>
+        <p:spPr>
+          <a:xfrm>
+            <a:off x="8558784" y="1435608"/>
+            <a:ext cx="164592" cy="0"/>
+          </a:xfrm>
+          <a:prstGeom prst="line">
+            <a:avLst/>
+          </a:prstGeom>
+          <a:ln w="15240">
+            <a:solidFill>
+              <a:srgbClr val="5A6978"/>
+            </a:solidFill>
+          </a:ln>
+        </p:spPr>
+        <p:style>
+          <a:lnRef idx="2">
+            <a:schemeClr val="accent1"/>
+          </a:lnRef>
+          <a:fillRef idx="0">
+            <a:schemeClr val="accent1"/>
+          </a:fillRef>
+          <a:effectRef idx="1">
+            <a:schemeClr val="accent1"/>
+          </a:effectRef>
+          <a:fontRef idx="minor">
+            <a:schemeClr val="tx1"/>
+          </a:fontRef>
+        </p:style>
+      </p:cxnSp>
+      <p:cxnSp>
+        <p:nvCxnSpPr>
+          <p:cNvPr id="32" name="Connector 31"/>
+          <p:cNvCxnSpPr/>
+          <p:nvPr/>
+        </p:nvCxnSpPr>
+        <p:spPr>
+          <a:xfrm>
+            <a:off x="4983480" y="2167128"/>
+            <a:ext cx="137160" cy="0"/>
+          </a:xfrm>
+          <a:prstGeom prst="line">
+            <a:avLst/>
+          </a:prstGeom>
+          <a:ln w="15240">
+            <a:solidFill>
+              <a:srgbClr val="5A6978"/>
+            </a:solidFill>
+          </a:ln>
+        </p:spPr>
+        <p:style>
+          <a:lnRef idx="2">
+            <a:schemeClr val="accent1"/>
+          </a:lnRef>
+          <a:fillRef idx="0">
+            <a:schemeClr val="accent1"/>
+          </a:fillRef>
+          <a:effectRef idx="1">
+            <a:schemeClr val="accent1"/>
+          </a:effectRef>
+          <a:fontRef idx="minor">
+            <a:schemeClr val="tx1"/>
+          </a:fontRef>
+        </p:style>
+      </p:cxnSp>
+      <p:sp>
+        <p:nvSpPr>
+          <p:cNvPr id="33" name="Rectangle 32"/>
+          <p:cNvSpPr/>
+          <p:nvPr/>
+        </p:nvSpPr>
+        <p:spPr>
+          <a:xfrm>
+            <a:off x="5120640" y="1965960"/>
+            <a:ext cx="960120" cy="402336"/>
+          </a:xfrm>
+          <a:prstGeom prst="rect">
+            <a:avLst/>
+          </a:prstGeom>
+          <a:solidFill>
+            <a:srgbClr val="FEEBA9"/>
+          </a:solidFill>
+          <a:ln w="15240">
+            <a:solidFill>
+              <a:srgbClr val="DAAF37"/>
+            </a:solidFill>
+          </a:ln>
+        </p:spPr>
+        <p:style>
+          <a:lnRef idx="1">
+            <a:schemeClr val="accent1"/>
+          </a:lnRef>
+          <a:fillRef idx="3">
+            <a:schemeClr val="accent1"/>
+          </a:fillRef>
+          <a:effectRef idx="2">
+            <a:schemeClr val="accent1"/>
+          </a:effectRef>
+          <a:fontRef idx="minor">
+            <a:schemeClr val="lt1"/>
+          </a:fontRef>
+        </p:style>
+        <p:txBody>
+          <a:bodyPr rtlCol="0" anchor="ctr" wrap="square"/>
+          <a:lstStyle/>
+          <a:p>
+            <a:pPr algn="ctr">
+              <a:defRPr sz="750" b="1">
+                <a:solidFill>
+                  <a:srgbClr val="1E293B"/>
+                </a:solidFill>
+                <a:latin typeface="Arial"/>
+              </a:defRPr>
+            </a:pPr>
+            <a:r>
+              <a:t>Entity Extraction</a:t>
+            </a:r>
+          </a:p>
+        </p:txBody>
+      </p:sp>
+      <p:sp>
+        <p:nvSpPr>
+          <p:cNvPr id="34" name="Rounded Rectangle 33"/>
+          <p:cNvSpPr/>
+          <p:nvPr/>
+        </p:nvSpPr>
+        <p:spPr>
+          <a:xfrm>
+            <a:off x="6245352" y="1965960"/>
+            <a:ext cx="1005840" cy="402336"/>
+          </a:xfrm>
+          <a:prstGeom prst="roundRect">
+            <a:avLst/>
+          </a:prstGeom>
+          <a:solidFill>
+            <a:srgbClr val="C8F5A0"/>
+          </a:solidFill>
+          <a:ln w="15240">
+            <a:solidFill>
+              <a:srgbClr val="64B43C"/>
+            </a:solidFill>
+          </a:ln>
+        </p:spPr>
+        <p:style>
+          <a:lnRef idx="1">
+            <a:schemeClr val="accent1"/>
+          </a:lnRef>
+          <a:fillRef idx="3">
+            <a:schemeClr val="accent1"/>
+          </a:fillRef>
+          <a:effectRef idx="2">
+            <a:schemeClr val="accent1"/>
+          </a:effectRef>
+          <a:fontRef idx="minor">
+            <a:schemeClr val="lt1"/>
+          </a:fontRef>
+        </p:style>
+        <p:txBody>
+          <a:bodyPr rtlCol="0" anchor="ctr" wrap="square"/>
+          <a:lstStyle/>
+          <a:p>
+            <a:pPr algn="ctr">
+              <a:defRPr sz="750" b="1">
+                <a:solidFill>
+                  <a:srgbClr val="1E293B"/>
+                </a:solidFill>
+                <a:latin typeface="Arial"/>
+              </a:defRPr>
+            </a:pPr>
+            <a:r>
+              <a:t>Regex + NER Rules</a:t>
+            </a:r>
+          </a:p>
+        </p:txBody>
+      </p:sp>
+      <p:cxnSp>
+        <p:nvCxnSpPr>
+          <p:cNvPr id="35" name="Connector 34"/>
+          <p:cNvCxnSpPr/>
+          <p:nvPr/>
+        </p:nvCxnSpPr>
+        <p:spPr>
+          <a:xfrm>
+            <a:off x="6080760" y="2167128"/>
+            <a:ext cx="164592" cy="0"/>
+          </a:xfrm>
+          <a:prstGeom prst="line">
+            <a:avLst/>
+          </a:prstGeom>
+          <a:ln w="15240">
+            <a:solidFill>
+              <a:srgbClr val="5A6978"/>
+            </a:solidFill>
+          </a:ln>
+        </p:spPr>
+        <p:style>
+          <a:lnRef idx="2">
+            <a:schemeClr val="accent1"/>
+          </a:lnRef>
+          <a:fillRef idx="0">
+            <a:schemeClr val="accent1"/>
+          </a:fillRef>
+          <a:effectRef idx="1">
+            <a:schemeClr val="accent1"/>
+          </a:effectRef>
+          <a:fontRef idx="minor">
+            <a:schemeClr val="tx1"/>
+          </a:fontRef>
+        </p:style>
+      </p:cxnSp>
+      <p:sp>
+        <p:nvSpPr>
+          <p:cNvPr id="36" name="Rounded Rectangle 35"/>
+          <p:cNvSpPr/>
+          <p:nvPr/>
+        </p:nvSpPr>
+        <p:spPr>
+          <a:xfrm>
+            <a:off x="7415784" y="1965960"/>
+            <a:ext cx="1143000" cy="402336"/>
+          </a:xfrm>
+          <a:prstGeom prst="roundRect">
+            <a:avLst/>
+          </a:prstGeom>
+          <a:solidFill>
+            <a:srgbClr val="99E6F2"/>
+          </a:solidFill>
+          <a:ln w="15240">
+            <a:solidFill>
+              <a:srgbClr val="00A0BE"/>
+            </a:solidFill>
+          </a:ln>
+        </p:spPr>
+        <p:style>
+          <a:lnRef idx="1">
+            <a:schemeClr val="accent1"/>
+          </a:lnRef>
+          <a:fillRef idx="3">
+            <a:schemeClr val="accent1"/>
+          </a:fillRef>
+          <a:effectRef idx="2">
+            <a:schemeClr val="accent1"/>
+          </a:effectRef>
+          <a:fontRef idx="minor">
+            <a:schemeClr val="lt1"/>
+          </a:fontRef>
+        </p:style>
+        <p:txBody>
+          <a:bodyPr rtlCol="0" anchor="ctr" wrap="square"/>
+          <a:lstStyle/>
+          <a:p>
+            <a:pPr algn="ctr">
+              <a:defRPr sz="750" b="1">
+                <a:solidFill>
+                  <a:srgbClr val="1E293B"/>
+                </a:solidFill>
+                <a:latin typeface="Arial"/>
+              </a:defRPr>
+            </a:pPr>
+            <a:r>
+              <a:t>Fuzzy Levenshtein</a:t>
+            </a:r>
+          </a:p>
+        </p:txBody>
+      </p:sp>
+      <p:cxnSp>
+        <p:nvCxnSpPr>
+          <p:cNvPr id="37" name="Connector 36"/>
+          <p:cNvCxnSpPr/>
+          <p:nvPr/>
+        </p:nvCxnSpPr>
+        <p:spPr>
+          <a:xfrm>
+            <a:off x="7251192" y="2167128"/>
+            <a:ext cx="164592" cy="0"/>
+          </a:xfrm>
+          <a:prstGeom prst="line">
+            <a:avLst/>
+          </a:prstGeom>
+          <a:ln w="15240">
+            <a:solidFill>
+              <a:srgbClr val="5A6978"/>
+            </a:solidFill>
+          </a:ln>
+        </p:spPr>
+        <p:style>
+          <a:lnRef idx="2">
+            <a:schemeClr val="accent1"/>
+          </a:lnRef>
+          <a:fillRef idx="0">
+            <a:schemeClr val="accent1"/>
+          </a:fillRef>
+          <a:effectRef idx="1">
+            <a:schemeClr val="accent1"/>
+          </a:effectRef>
+          <a:fontRef idx="minor">
+            <a:schemeClr val="tx1"/>
+          </a:fontRef>
+        </p:style>
+      </p:cxnSp>
+      <p:sp>
+        <p:nvSpPr>
+          <p:cNvPr id="38" name="Rounded Rectangle 37"/>
+          <p:cNvSpPr/>
+          <p:nvPr/>
+        </p:nvSpPr>
+        <p:spPr>
+          <a:xfrm>
+            <a:off x="8723376" y="1965960"/>
+            <a:ext cx="960120" cy="402336"/>
+          </a:xfrm>
+          <a:prstGeom prst="roundRect">
+            <a:avLst/>
+          </a:prstGeom>
+          <a:solidFill>
+            <a:srgbClr val="C8AFE1"/>
+          </a:solidFill>
+          <a:ln w="15240">
+            <a:solidFill>
+              <a:srgbClr val="8C64B4"/>
+            </a:solidFill>
+          </a:ln>
+        </p:spPr>
+        <p:style>
+          <a:lnRef idx="1">
+            <a:schemeClr val="accent1"/>
+          </a:lnRef>
+          <a:fillRef idx="3">
+            <a:schemeClr val="accent1"/>
+          </a:fillRef>
+          <a:effectRef idx="2">
+            <a:schemeClr val="accent1"/>
+          </a:effectRef>
+          <a:fontRef idx="minor">
+            <a:schemeClr val="lt1"/>
+          </a:fontRef>
+        </p:style>
+        <p:txBody>
+          <a:bodyPr rtlCol="0" anchor="ctr" wrap="square"/>
+          <a:lstStyle/>
+          <a:p>
+            <a:pPr algn="ctr">
+              <a:defRPr sz="750" b="1">
+                <a:solidFill>
+                  <a:srgbClr val="1E293B"/>
+                </a:solidFill>
+                <a:latin typeface="Arial"/>
+              </a:defRPr>
+            </a:pPr>
+            <a:r>
+              <a:t>Resolved Graph</a:t>
+            </a:r>
+          </a:p>
+        </p:txBody>
+      </p:sp>
+      <p:cxnSp>
+        <p:nvCxnSpPr>
+          <p:cNvPr id="39" name="Connector 38"/>
+          <p:cNvCxnSpPr/>
+          <p:nvPr/>
+        </p:nvCxnSpPr>
+        <p:spPr>
+          <a:xfrm>
+            <a:off x="8558784" y="2167128"/>
+            <a:ext cx="164592" cy="0"/>
+          </a:xfrm>
+          <a:prstGeom prst="line">
+            <a:avLst/>
+          </a:prstGeom>
+          <a:ln w="15240">
+            <a:solidFill>
+              <a:srgbClr val="5A6978"/>
+            </a:solidFill>
+          </a:ln>
+        </p:spPr>
+        <p:style>
+          <a:lnRef idx="2">
+            <a:schemeClr val="accent1"/>
+          </a:lnRef>
+          <a:fillRef idx="0">
+            <a:schemeClr val="accent1"/>
+          </a:fillRef>
+          <a:effectRef idx="1">
+            <a:schemeClr val="accent1"/>
+          </a:effectRef>
+          <a:fontRef idx="minor">
+            <a:schemeClr val="tx1"/>
+          </a:fontRef>
+        </p:style>
+      </p:cxnSp>
+      <p:cxnSp>
+        <p:nvCxnSpPr>
+          <p:cNvPr id="40" name="Connector 39"/>
+          <p:cNvCxnSpPr/>
+          <p:nvPr/>
+        </p:nvCxnSpPr>
+        <p:spPr>
+          <a:xfrm>
+            <a:off x="4983480" y="2898648"/>
+            <a:ext cx="137160" cy="0"/>
+          </a:xfrm>
+          <a:prstGeom prst="line">
+            <a:avLst/>
+          </a:prstGeom>
+          <a:ln w="15240">
+            <a:solidFill>
+              <a:srgbClr val="5A6978"/>
+            </a:solidFill>
+          </a:ln>
+        </p:spPr>
+        <p:style>
+          <a:lnRef idx="2">
+            <a:schemeClr val="accent1"/>
+          </a:lnRef>
+          <a:fillRef idx="0">
+            <a:schemeClr val="accent1"/>
+          </a:fillRef>
+          <a:effectRef idx="1">
+            <a:schemeClr val="accent1"/>
+          </a:effectRef>
+          <a:fontRef idx="minor">
+            <a:schemeClr val="tx1"/>
+          </a:fontRef>
+        </p:style>
+      </p:cxnSp>
+      <p:sp>
+        <p:nvSpPr>
+          <p:cNvPr id="41" name="Rectangle 40"/>
+          <p:cNvSpPr/>
+          <p:nvPr/>
+        </p:nvSpPr>
+        <p:spPr>
+          <a:xfrm>
+            <a:off x="5120640" y="2697480"/>
+            <a:ext cx="960120" cy="402336"/>
+          </a:xfrm>
+          <a:prstGeom prst="rect">
+            <a:avLst/>
+          </a:prstGeom>
+          <a:solidFill>
+            <a:srgbClr val="FEEBA9"/>
+          </a:solidFill>
+          <a:ln w="15240">
+            <a:solidFill>
+              <a:srgbClr val="DAAF37"/>
+            </a:solidFill>
+          </a:ln>
+        </p:spPr>
+        <p:style>
+          <a:lnRef idx="1">
+            <a:schemeClr val="accent1"/>
+          </a:lnRef>
+          <a:fillRef idx="3">
+            <a:schemeClr val="accent1"/>
+          </a:fillRef>
+          <a:effectRef idx="2">
+            <a:schemeClr val="accent1"/>
+          </a:effectRef>
+          <a:fontRef idx="minor">
+            <a:schemeClr val="lt1"/>
+          </a:fontRef>
+        </p:style>
+        <p:txBody>
+          <a:bodyPr rtlCol="0" anchor="ctr" wrap="square"/>
+          <a:lstStyle/>
+          <a:p>
+            <a:pPr algn="ctr">
+              <a:defRPr sz="750" b="1">
+                <a:solidFill>
+                  <a:srgbClr val="1E293B"/>
+                </a:solidFill>
+                <a:latin typeface="Arial"/>
+              </a:defRPr>
+            </a:pPr>
+            <a:r>
+              <a:t>Graph Engine</a:t>
+            </a:r>
+          </a:p>
+        </p:txBody>
+      </p:sp>
+      <p:sp>
+        <p:nvSpPr>
+          <p:cNvPr id="42" name="Rounded Rectangle 41"/>
+          <p:cNvSpPr/>
+          <p:nvPr/>
+        </p:nvSpPr>
+        <p:spPr>
+          <a:xfrm>
+            <a:off x="6245352" y="2697480"/>
+            <a:ext cx="1280160" cy="402336"/>
+          </a:xfrm>
+          <a:prstGeom prst="roundRect">
+            <a:avLst/>
+          </a:prstGeom>
+          <a:solidFill>
+            <a:srgbClr val="C8F5A0"/>
+          </a:solidFill>
+          <a:ln w="15240">
+            <a:solidFill>
+              <a:srgbClr val="64B43C"/>
+            </a:solidFill>
+          </a:ln>
+        </p:spPr>
+        <p:style>
+          <a:lnRef idx="1">
+            <a:schemeClr val="accent1"/>
+          </a:lnRef>
+          <a:fillRef idx="3">
+            <a:schemeClr val="accent1"/>
+          </a:fillRef>
+          <a:effectRef idx="2">
+            <a:schemeClr val="accent1"/>
+          </a:effectRef>
+          <a:fontRef idx="minor">
+            <a:schemeClr val="lt1"/>
+          </a:fontRef>
+        </p:style>
+        <p:txBody>
+          <a:bodyPr rtlCol="0" anchor="ctr" wrap="square"/>
+          <a:lstStyle/>
+          <a:p>
+            <a:pPr algn="ctr">
+              <a:defRPr sz="750" b="1">
+                <a:solidFill>
+                  <a:srgbClr val="1E293B"/>
+                </a:solidFill>
+                <a:latin typeface="Arial"/>
+              </a:defRPr>
+            </a:pPr>
+            <a:r>
+              <a:t>NetworkX MultiDiGraph</a:t>
+            </a:r>
+          </a:p>
+        </p:txBody>
+      </p:sp>
+      <p:cxnSp>
+        <p:nvCxnSpPr>
+          <p:cNvPr id="43" name="Connector 42"/>
+          <p:cNvCxnSpPr/>
+          <p:nvPr/>
+        </p:nvCxnSpPr>
+        <p:spPr>
+          <a:xfrm>
+            <a:off x="6080760" y="2898648"/>
+            <a:ext cx="164592" cy="0"/>
+          </a:xfrm>
+          <a:prstGeom prst="line">
+            <a:avLst/>
+          </a:prstGeom>
+          <a:ln w="15240">
+            <a:solidFill>
+              <a:srgbClr val="5A6978"/>
+            </a:solidFill>
+          </a:ln>
+        </p:spPr>
+        <p:style>
+          <a:lnRef idx="2">
+            <a:schemeClr val="accent1"/>
+          </a:lnRef>
+          <a:fillRef idx="0">
+            <a:schemeClr val="accent1"/>
+          </a:fillRef>
+          <a:effectRef idx="1">
+            <a:schemeClr val="accent1"/>
+          </a:effectRef>
+          <a:fontRef idx="minor">
+            <a:schemeClr val="tx1"/>
+          </a:fontRef>
+        </p:style>
+      </p:cxnSp>
+      <p:sp>
+        <p:nvSpPr>
+          <p:cNvPr id="44" name="Rounded Rectangle 43"/>
+          <p:cNvSpPr/>
+          <p:nvPr/>
+        </p:nvSpPr>
+        <p:spPr>
+          <a:xfrm>
+            <a:off x="7690104" y="2697480"/>
+            <a:ext cx="1051560" cy="402336"/>
+          </a:xfrm>
+          <a:prstGeom prst="roundRect">
+            <a:avLst/>
+          </a:prstGeom>
+          <a:solidFill>
+            <a:srgbClr val="99E6F2"/>
+          </a:solidFill>
+          <a:ln w="15240">
+            <a:solidFill>
+              <a:srgbClr val="00A0BE"/>
+            </a:solidFill>
+          </a:ln>
+        </p:spPr>
+        <p:style>
+          <a:lnRef idx="1">
+            <a:schemeClr val="accent1"/>
+          </a:lnRef>
+          <a:fillRef idx="3">
+            <a:schemeClr val="accent1"/>
+          </a:fillRef>
+          <a:effectRef idx="2">
+            <a:schemeClr val="accent1"/>
+          </a:effectRef>
+          <a:fontRef idx="minor">
+            <a:schemeClr val="lt1"/>
+          </a:fontRef>
+        </p:style>
+        <p:txBody>
+          <a:bodyPr rtlCol="0" anchor="ctr" wrap="square"/>
+          <a:lstStyle/>
+          <a:p>
+            <a:pPr algn="ctr">
+              <a:defRPr sz="750" b="1">
+                <a:solidFill>
+                  <a:srgbClr val="1E293B"/>
+                </a:solidFill>
+                <a:latin typeface="Arial"/>
+              </a:defRPr>
+            </a:pPr>
+            <a:r>
+              <a:t>Attributed Edges</a:t>
+            </a:r>
+          </a:p>
+        </p:txBody>
+      </p:sp>
+      <p:cxnSp>
+        <p:nvCxnSpPr>
+          <p:cNvPr id="45" name="Connector 44"/>
+          <p:cNvCxnSpPr/>
+          <p:nvPr/>
+        </p:nvCxnSpPr>
+        <p:spPr>
+          <a:xfrm>
+            <a:off x="7525512" y="2898648"/>
+            <a:ext cx="164592" cy="0"/>
+          </a:xfrm>
+          <a:prstGeom prst="line">
+            <a:avLst/>
+          </a:prstGeom>
+          <a:ln w="15240">
+            <a:solidFill>
+              <a:srgbClr val="5A6978"/>
+            </a:solidFill>
+          </a:ln>
+        </p:spPr>
+        <p:style>
+          <a:lnRef idx="2">
+            <a:schemeClr val="accent1"/>
+          </a:lnRef>
+          <a:fillRef idx="0">
+            <a:schemeClr val="accent1"/>
+          </a:fillRef>
+          <a:effectRef idx="1">
+            <a:schemeClr val="accent1"/>
+          </a:effectRef>
+          <a:fontRef idx="minor">
+            <a:schemeClr val="tx1"/>
+          </a:fontRef>
+        </p:style>
+      </p:cxnSp>
+      <p:cxnSp>
+        <p:nvCxnSpPr>
+          <p:cNvPr id="46" name="Connector 45"/>
+          <p:cNvCxnSpPr/>
+          <p:nvPr/>
+        </p:nvCxnSpPr>
+        <p:spPr>
+          <a:xfrm>
+            <a:off x="4983480" y="3630168"/>
+            <a:ext cx="137160" cy="0"/>
+          </a:xfrm>
+          <a:prstGeom prst="line">
+            <a:avLst/>
+          </a:prstGeom>
+          <a:ln w="15240">
+            <a:solidFill>
+              <a:srgbClr val="5A6978"/>
+            </a:solidFill>
+          </a:ln>
+        </p:spPr>
+        <p:style>
+          <a:lnRef idx="2">
+            <a:schemeClr val="accent1"/>
+          </a:lnRef>
+          <a:fillRef idx="0">
+            <a:schemeClr val="accent1"/>
+          </a:fillRef>
+          <a:effectRef idx="1">
+            <a:schemeClr val="accent1"/>
+          </a:effectRef>
+          <a:fontRef idx="minor">
+            <a:schemeClr val="tx1"/>
+          </a:fontRef>
+        </p:style>
+      </p:cxnSp>
+      <p:sp>
+        <p:nvSpPr>
+          <p:cNvPr id="47" name="Rectangle 46"/>
+          <p:cNvSpPr/>
+          <p:nvPr/>
+        </p:nvSpPr>
+        <p:spPr>
+          <a:xfrm>
+            <a:off x="5120640" y="3429000"/>
+            <a:ext cx="960120" cy="402336"/>
+          </a:xfrm>
+          <a:prstGeom prst="rect">
+            <a:avLst/>
+          </a:prstGeom>
+          <a:solidFill>
+            <a:srgbClr val="FEEBA9"/>
+          </a:solidFill>
+          <a:ln w="15240">
+            <a:solidFill>
+              <a:srgbClr val="DAAF37"/>
+            </a:solidFill>
+          </a:ln>
+        </p:spPr>
+        <p:style>
+          <a:lnRef idx="1">
+            <a:schemeClr val="accent1"/>
+          </a:lnRef>
+          <a:fillRef idx="3">
+            <a:schemeClr val="accent1"/>
+          </a:fillRef>
+          <a:effectRef idx="2">
+            <a:schemeClr val="accent1"/>
+          </a:effectRef>
+          <a:fontRef idx="minor">
+            <a:schemeClr val="lt1"/>
+          </a:fontRef>
+        </p:style>
+        <p:txBody>
+          <a:bodyPr rtlCol="0" anchor="ctr" wrap="square"/>
+          <a:lstStyle/>
+          <a:p>
+            <a:pPr algn="ctr">
+              <a:defRPr sz="750" b="1">
+                <a:solidFill>
+                  <a:srgbClr val="1E293B"/>
+                </a:solidFill>
+                <a:latin typeface="Arial"/>
+              </a:defRPr>
+            </a:pPr>
+            <a:r>
+              <a:t>Centrality Suite</a:t>
+            </a:r>
+          </a:p>
+        </p:txBody>
+      </p:sp>
+      <p:sp>
+        <p:nvSpPr>
+          <p:cNvPr id="48" name="Rounded Rectangle 47"/>
+          <p:cNvSpPr/>
+          <p:nvPr/>
+        </p:nvSpPr>
+        <p:spPr>
+          <a:xfrm>
+            <a:off x="6245352" y="3429000"/>
+            <a:ext cx="1143000" cy="402336"/>
+          </a:xfrm>
+          <a:prstGeom prst="roundRect">
+            <a:avLst/>
+          </a:prstGeom>
+          <a:solidFill>
+            <a:srgbClr val="C8F5A0"/>
+          </a:solidFill>
+          <a:ln w="15240">
+            <a:solidFill>
+              <a:srgbClr val="64B43C"/>
+            </a:solidFill>
+          </a:ln>
+        </p:spPr>
+        <p:style>
+          <a:lnRef idx="1">
+            <a:schemeClr val="accent1"/>
+          </a:lnRef>
+          <a:fillRef idx="3">
+            <a:schemeClr val="accent1"/>
+          </a:fillRef>
+          <a:effectRef idx="2">
+            <a:schemeClr val="accent1"/>
+          </a:effectRef>
+          <a:fontRef idx="minor">
+            <a:schemeClr val="lt1"/>
+          </a:fontRef>
+        </p:style>
+        <p:txBody>
+          <a:bodyPr rtlCol="0" anchor="ctr" wrap="square"/>
+          <a:lstStyle/>
+          <a:p>
+            <a:pPr algn="ctr">
+              <a:defRPr sz="750" b="1">
+                <a:solidFill>
+                  <a:srgbClr val="1E293B"/>
+                </a:solidFill>
+                <a:latin typeface="Arial"/>
+              </a:defRPr>
+            </a:pPr>
+            <a:r>
+              <a:t>Degree/Betweenness</a:t>
+            </a:r>
+          </a:p>
+        </p:txBody>
+      </p:sp>
+      <p:cxnSp>
+        <p:nvCxnSpPr>
+          <p:cNvPr id="49" name="Connector 48"/>
+          <p:cNvCxnSpPr/>
+          <p:nvPr/>
+        </p:nvCxnSpPr>
+        <p:spPr>
+          <a:xfrm>
+            <a:off x="6080760" y="3630168"/>
+            <a:ext cx="164592" cy="0"/>
+          </a:xfrm>
+          <a:prstGeom prst="line">
+            <a:avLst/>
+          </a:prstGeom>
+          <a:ln w="15240">
+            <a:solidFill>
+              <a:srgbClr val="5A6978"/>
+            </a:solidFill>
+          </a:ln>
+        </p:spPr>
+        <p:style>
+          <a:lnRef idx="2">
+            <a:schemeClr val="accent1"/>
+          </a:lnRef>
+          <a:fillRef idx="0">
+            <a:schemeClr val="accent1"/>
+          </a:fillRef>
+          <a:effectRef idx="1">
+            <a:schemeClr val="accent1"/>
+          </a:effectRef>
+          <a:fontRef idx="minor">
+            <a:schemeClr val="tx1"/>
+          </a:fontRef>
+        </p:style>
+      </p:cxnSp>
+      <p:sp>
+        <p:nvSpPr>
+          <p:cNvPr id="50" name="Rounded Rectangle 49"/>
+          <p:cNvSpPr/>
+          <p:nvPr/>
+        </p:nvSpPr>
+        <p:spPr>
+          <a:xfrm>
+            <a:off x="7552944" y="3429000"/>
+            <a:ext cx="1188720" cy="402336"/>
+          </a:xfrm>
+          <a:prstGeom prst="roundRect">
+            <a:avLst/>
+          </a:prstGeom>
+          <a:solidFill>
+            <a:srgbClr val="C8F5A0"/>
+          </a:solidFill>
+          <a:ln w="15240">
+            <a:solidFill>
+              <a:srgbClr val="64B43C"/>
+            </a:solidFill>
+          </a:ln>
+        </p:spPr>
+        <p:style>
+          <a:lnRef idx="1">
+            <a:schemeClr val="accent1"/>
+          </a:lnRef>
+          <a:fillRef idx="3">
+            <a:schemeClr val="accent1"/>
+          </a:fillRef>
+          <a:effectRef idx="2">
+            <a:schemeClr val="accent1"/>
+          </a:effectRef>
+          <a:fontRef idx="minor">
+            <a:schemeClr val="lt1"/>
+          </a:fontRef>
+        </p:style>
+        <p:txBody>
+          <a:bodyPr rtlCol="0" anchor="ctr" wrap="square"/>
+          <a:lstStyle/>
+          <a:p>
+            <a:pPr algn="ctr">
+              <a:defRPr sz="750" b="1">
+                <a:solidFill>
+                  <a:srgbClr val="1E293B"/>
+                </a:solidFill>
+                <a:latin typeface="Arial"/>
+              </a:defRPr>
+            </a:pPr>
+            <a:r>
+              <a:t>Louvain Communities</a:t>
+            </a:r>
+          </a:p>
+        </p:txBody>
+      </p:sp>
+      <p:cxnSp>
+        <p:nvCxnSpPr>
+          <p:cNvPr id="51" name="Connector 50"/>
+          <p:cNvCxnSpPr/>
+          <p:nvPr/>
+        </p:nvCxnSpPr>
+        <p:spPr>
+          <a:xfrm>
+            <a:off x="7388352" y="3630168"/>
+            <a:ext cx="164592" cy="0"/>
+          </a:xfrm>
+          <a:prstGeom prst="line">
+            <a:avLst/>
+          </a:prstGeom>
+          <a:ln w="15240">
+            <a:solidFill>
+              <a:srgbClr val="5A6978"/>
+            </a:solidFill>
+          </a:ln>
+        </p:spPr>
+        <p:style>
+          <a:lnRef idx="2">
+            <a:schemeClr val="accent1"/>
+          </a:lnRef>
+          <a:fillRef idx="0">
+            <a:schemeClr val="accent1"/>
+          </a:fillRef>
+          <a:effectRef idx="1">
+            <a:schemeClr val="accent1"/>
+          </a:effectRef>
+          <a:fontRef idx="minor">
+            <a:schemeClr val="tx1"/>
+          </a:fontRef>
+        </p:style>
+      </p:cxnSp>
+      <p:sp>
+        <p:nvSpPr>
+          <p:cNvPr id="52" name="Rounded Rectangle 51"/>
+          <p:cNvSpPr/>
+          <p:nvPr/>
+        </p:nvSpPr>
+        <p:spPr>
+          <a:xfrm>
+            <a:off x="8906256" y="3429000"/>
+            <a:ext cx="868680" cy="402336"/>
+          </a:xfrm>
+          <a:prstGeom prst="roundRect">
+            <a:avLst/>
+          </a:prstGeom>
+          <a:solidFill>
+            <a:srgbClr val="C8AFE1"/>
+          </a:solidFill>
+          <a:ln w="15240">
+            <a:solidFill>
+              <a:srgbClr val="8C64B4"/>
+            </a:solidFill>
+          </a:ln>
+        </p:spPr>
+        <p:style>
+          <a:lnRef idx="1">
+            <a:schemeClr val="accent1"/>
+          </a:lnRef>
+          <a:fillRef idx="3">
+            <a:schemeClr val="accent1"/>
+          </a:fillRef>
+          <a:effectRef idx="2">
+            <a:schemeClr val="accent1"/>
+          </a:effectRef>
+          <a:fontRef idx="minor">
+            <a:schemeClr val="lt1"/>
+          </a:fontRef>
+        </p:style>
+        <p:txBody>
+          <a:bodyPr rtlCol="0" anchor="ctr" wrap="square"/>
+          <a:lstStyle/>
+          <a:p>
+            <a:pPr algn="ctr">
+              <a:defRPr sz="750" b="1">
+                <a:solidFill>
+                  <a:srgbClr val="1E293B"/>
+                </a:solidFill>
+                <a:latin typeface="Arial"/>
+              </a:defRPr>
+            </a:pPr>
+            <a:r>
+              <a:t>Key Players</a:t>
+            </a:r>
+          </a:p>
+        </p:txBody>
+      </p:sp>
+      <p:cxnSp>
+        <p:nvCxnSpPr>
+          <p:cNvPr id="53" name="Connector 52"/>
+          <p:cNvCxnSpPr/>
+          <p:nvPr/>
+        </p:nvCxnSpPr>
+        <p:spPr>
+          <a:xfrm>
+            <a:off x="8741664" y="3630168"/>
+            <a:ext cx="164592" cy="0"/>
+          </a:xfrm>
+          <a:prstGeom prst="line">
+            <a:avLst/>
+          </a:prstGeom>
+          <a:ln w="15240">
+            <a:solidFill>
+              <a:srgbClr val="5A6978"/>
+            </a:solidFill>
+          </a:ln>
+        </p:spPr>
+        <p:style>
+          <a:lnRef idx="2">
+            <a:schemeClr val="accent1"/>
+          </a:lnRef>
+          <a:fillRef idx="0">
+            <a:schemeClr val="accent1"/>
+          </a:fillRef>
+          <a:effectRef idx="1">
+            <a:schemeClr val="accent1"/>
+          </a:effectRef>
+          <a:fontRef idx="minor">
+            <a:schemeClr val="tx1"/>
+          </a:fontRef>
+        </p:style>
+      </p:cxnSp>
+      <p:cxnSp>
+        <p:nvCxnSpPr>
+          <p:cNvPr id="54" name="Connector 53"/>
+          <p:cNvCxnSpPr/>
+          <p:nvPr/>
+        </p:nvCxnSpPr>
+        <p:spPr>
+          <a:xfrm>
+            <a:off x="4983480" y="4361688"/>
+            <a:ext cx="137160" cy="0"/>
+          </a:xfrm>
+          <a:prstGeom prst="line">
+            <a:avLst/>
+          </a:prstGeom>
+          <a:ln w="15240">
+            <a:solidFill>
+              <a:srgbClr val="5A6978"/>
+            </a:solidFill>
+          </a:ln>
+        </p:spPr>
+        <p:style>
+          <a:lnRef idx="2">
+            <a:schemeClr val="accent1"/>
+          </a:lnRef>
+          <a:fillRef idx="0">
+            <a:schemeClr val="accent1"/>
+          </a:fillRef>
+          <a:effectRef idx="1">
+            <a:schemeClr val="accent1"/>
+          </a:effectRef>
+          <a:fontRef idx="minor">
+            <a:schemeClr val="tx1"/>
+          </a:fontRef>
+        </p:style>
+      </p:cxnSp>
+      <p:sp>
+        <p:nvSpPr>
+          <p:cNvPr id="55" name="Rectangle 54"/>
+          <p:cNvSpPr/>
+          <p:nvPr/>
+        </p:nvSpPr>
+        <p:spPr>
+          <a:xfrm>
+            <a:off x="5120640" y="4160520"/>
+            <a:ext cx="1005840" cy="402336"/>
+          </a:xfrm>
+          <a:prstGeom prst="rect">
+            <a:avLst/>
+          </a:prstGeom>
+          <a:solidFill>
+            <a:srgbClr val="FEEBA9"/>
+          </a:solidFill>
+          <a:ln w="15240">
+            <a:solidFill>
+              <a:srgbClr val="DAAF37"/>
+            </a:solidFill>
+          </a:ln>
+        </p:spPr>
+        <p:style>
+          <a:lnRef idx="1">
+            <a:schemeClr val="accent1"/>
+          </a:lnRef>
+          <a:fillRef idx="3">
+            <a:schemeClr val="accent1"/>
+          </a:fillRef>
+          <a:effectRef idx="2">
+            <a:schemeClr val="accent1"/>
+          </a:effectRef>
+          <a:fontRef idx="minor">
+            <a:schemeClr val="lt1"/>
+          </a:fontRef>
+        </p:style>
+        <p:txBody>
+          <a:bodyPr rtlCol="0" anchor="ctr" wrap="square"/>
+          <a:lstStyle/>
+          <a:p>
+            <a:pPr algn="ctr">
+              <a:defRPr sz="750" b="1">
+                <a:solidFill>
+                  <a:srgbClr val="1E293B"/>
+                </a:solidFill>
+                <a:latin typeface="Arial"/>
+              </a:defRPr>
+            </a:pPr>
+            <a:r>
+              <a:t>Forensic Graph ML</a:t>
+            </a:r>
+          </a:p>
+        </p:txBody>
+      </p:sp>
+      <p:sp>
+        <p:nvSpPr>
+          <p:cNvPr id="56" name="Rounded Rectangle 55"/>
+          <p:cNvSpPr/>
+          <p:nvPr/>
+        </p:nvSpPr>
+        <p:spPr>
+          <a:xfrm>
+            <a:off x="6291072" y="4160520"/>
+            <a:ext cx="1280160" cy="402336"/>
+          </a:xfrm>
+          <a:prstGeom prst="roundRect">
+            <a:avLst/>
+          </a:prstGeom>
+          <a:solidFill>
+            <a:srgbClr val="C8F5A0"/>
+          </a:solidFill>
+          <a:ln w="15240">
+            <a:solidFill>
+              <a:srgbClr val="64B43C"/>
+            </a:solidFill>
+          </a:ln>
+        </p:spPr>
+        <p:style>
+          <a:lnRef idx="1">
+            <a:schemeClr val="accent1"/>
+          </a:lnRef>
+          <a:fillRef idx="3">
+            <a:schemeClr val="accent1"/>
+          </a:fillRef>
+          <a:effectRef idx="2">
+            <a:schemeClr val="accent1"/>
+          </a:effectRef>
+          <a:fontRef idx="minor">
+            <a:schemeClr val="lt1"/>
+          </a:fontRef>
+        </p:style>
+        <p:txBody>
+          <a:bodyPr rtlCol="0" anchor="ctr" wrap="square"/>
+          <a:lstStyle/>
+          <a:p>
+            <a:pPr algn="ctr">
+              <a:defRPr sz="750" b="1">
+                <a:solidFill>
+                  <a:srgbClr val="1E293B"/>
+                </a:solidFill>
+                <a:latin typeface="Arial"/>
+              </a:defRPr>
+            </a:pPr>
+            <a:r>
+              <a:t>Tarjan Laundering Loops</a:t>
+            </a:r>
+          </a:p>
+        </p:txBody>
+      </p:sp>
+      <p:cxnSp>
+        <p:nvCxnSpPr>
+          <p:cNvPr id="57" name="Connector 56"/>
+          <p:cNvCxnSpPr/>
+          <p:nvPr/>
+        </p:nvCxnSpPr>
+        <p:spPr>
+          <a:xfrm>
+            <a:off x="6126480" y="4361688"/>
+            <a:ext cx="164592" cy="0"/>
+          </a:xfrm>
+          <a:prstGeom prst="line">
+            <a:avLst/>
+          </a:prstGeom>
+          <a:ln w="15240">
+            <a:solidFill>
+              <a:srgbClr val="5A6978"/>
+            </a:solidFill>
+          </a:ln>
+        </p:spPr>
+        <p:style>
+          <a:lnRef idx="2">
+            <a:schemeClr val="accent1"/>
+          </a:lnRef>
+          <a:fillRef idx="0">
+            <a:schemeClr val="accent1"/>
+          </a:fillRef>
+          <a:effectRef idx="1">
+            <a:schemeClr val="accent1"/>
+          </a:effectRef>
+          <a:fontRef idx="minor">
+            <a:schemeClr val="tx1"/>
+          </a:fontRef>
+        </p:style>
+      </p:cxnSp>
+      <p:sp>
+        <p:nvSpPr>
+          <p:cNvPr id="58" name="Rounded Rectangle 57"/>
+          <p:cNvSpPr/>
+          <p:nvPr/>
+        </p:nvSpPr>
+        <p:spPr>
+          <a:xfrm>
+            <a:off x="7735824" y="4160520"/>
+            <a:ext cx="1051560" cy="402336"/>
+          </a:xfrm>
+          <a:prstGeom prst="roundRect">
+            <a:avLst/>
+          </a:prstGeom>
+          <a:solidFill>
+            <a:srgbClr val="99E6F2"/>
+          </a:solidFill>
+          <a:ln w="15240">
+            <a:solidFill>
+              <a:srgbClr val="00A0BE"/>
+            </a:solidFill>
+          </a:ln>
+        </p:spPr>
+        <p:style>
+          <a:lnRef idx="1">
+            <a:schemeClr val="accent1"/>
+          </a:lnRef>
+          <a:fillRef idx="3">
+            <a:schemeClr val="accent1"/>
+          </a:fillRef>
+          <a:effectRef idx="2">
+            <a:schemeClr val="accent1"/>
+          </a:effectRef>
+          <a:fontRef idx="minor">
+            <a:schemeClr val="lt1"/>
+          </a:fontRef>
+        </p:style>
+        <p:txBody>
+          <a:bodyPr rtlCol="0" anchor="ctr" wrap="square"/>
+          <a:lstStyle/>
+          <a:p>
+            <a:pPr algn="ctr">
+              <a:defRPr sz="750" b="1">
+                <a:solidFill>
+                  <a:srgbClr val="1E293B"/>
+                </a:solidFill>
+                <a:latin typeface="Arial"/>
+              </a:defRPr>
+            </a:pPr>
+            <a:r>
+              <a:t>Adamic-Adar Links</a:t>
+            </a:r>
+          </a:p>
+        </p:txBody>
+      </p:sp>
+      <p:cxnSp>
+        <p:nvCxnSpPr>
+          <p:cNvPr id="59" name="Connector 58"/>
+          <p:cNvCxnSpPr/>
+          <p:nvPr/>
+        </p:nvCxnSpPr>
+        <p:spPr>
+          <a:xfrm>
+            <a:off x="7571232" y="4361688"/>
+            <a:ext cx="164592" cy="0"/>
+          </a:xfrm>
+          <a:prstGeom prst="line">
+            <a:avLst/>
+          </a:prstGeom>
+          <a:ln w="15240">
+            <a:solidFill>
+              <a:srgbClr val="5A6978"/>
+            </a:solidFill>
+          </a:ln>
+        </p:spPr>
+        <p:style>
+          <a:lnRef idx="2">
+            <a:schemeClr val="accent1"/>
+          </a:lnRef>
+          <a:fillRef idx="0">
+            <a:schemeClr val="accent1"/>
+          </a:fillRef>
+          <a:effectRef idx="1">
+            <a:schemeClr val="accent1"/>
+          </a:effectRef>
+          <a:fontRef idx="minor">
+            <a:schemeClr val="tx1"/>
+          </a:fontRef>
+        </p:style>
+      </p:cxnSp>
+      <p:sp>
+        <p:nvSpPr>
+          <p:cNvPr id="60" name="Rounded Rectangle 59"/>
+          <p:cNvSpPr/>
+          <p:nvPr/>
+        </p:nvSpPr>
+        <p:spPr>
+          <a:xfrm>
+            <a:off x="8951976" y="4160520"/>
+            <a:ext cx="868680" cy="402336"/>
+          </a:xfrm>
+          <a:prstGeom prst="roundRect">
+            <a:avLst/>
+          </a:prstGeom>
+          <a:solidFill>
+            <a:srgbClr val="C8AFE1"/>
+          </a:solidFill>
+          <a:ln w="15240">
+            <a:solidFill>
+              <a:srgbClr val="8C64B4"/>
+            </a:solidFill>
+          </a:ln>
+        </p:spPr>
+        <p:style>
+          <a:lnRef idx="1">
+            <a:schemeClr val="accent1"/>
+          </a:lnRef>
+          <a:fillRef idx="3">
+            <a:schemeClr val="accent1"/>
+          </a:fillRef>
+          <a:effectRef idx="2">
+            <a:schemeClr val="accent1"/>
+          </a:effectRef>
+          <a:fontRef idx="minor">
+            <a:schemeClr val="lt1"/>
+          </a:fontRef>
+        </p:style>
+        <p:txBody>
+          <a:bodyPr rtlCol="0" anchor="ctr" wrap="square"/>
+          <a:lstStyle/>
+          <a:p>
+            <a:pPr algn="ctr">
+              <a:defRPr sz="750" b="1">
+                <a:solidFill>
+                  <a:srgbClr val="1E293B"/>
+                </a:solidFill>
+                <a:latin typeface="Arial"/>
+              </a:defRPr>
+            </a:pPr>
+            <a:r>
+              <a:t>Smurfing Alert</a:t>
+            </a:r>
+          </a:p>
+        </p:txBody>
+      </p:sp>
+      <p:cxnSp>
+        <p:nvCxnSpPr>
+          <p:cNvPr id="61" name="Connector 60"/>
+          <p:cNvCxnSpPr/>
+          <p:nvPr/>
+        </p:nvCxnSpPr>
+        <p:spPr>
+          <a:xfrm>
+            <a:off x="8787384" y="4361688"/>
+            <a:ext cx="164592" cy="0"/>
+          </a:xfrm>
+          <a:prstGeom prst="line">
+            <a:avLst/>
+          </a:prstGeom>
+          <a:ln w="15240">
+            <a:solidFill>
+              <a:srgbClr val="5A6978"/>
+            </a:solidFill>
+          </a:ln>
+        </p:spPr>
+        <p:style>
+          <a:lnRef idx="2">
+            <a:schemeClr val="accent1"/>
+          </a:lnRef>
+          <a:fillRef idx="0">
+            <a:schemeClr val="accent1"/>
+          </a:fillRef>
+          <a:effectRef idx="1">
+            <a:schemeClr val="accent1"/>
+          </a:effectRef>
+          <a:fontRef idx="minor">
+            <a:schemeClr val="tx1"/>
+          </a:fontRef>
+        </p:style>
+      </p:cxnSp>
+      <p:cxnSp>
+        <p:nvCxnSpPr>
+          <p:cNvPr id="62" name="Connector 61"/>
+          <p:cNvCxnSpPr/>
+          <p:nvPr/>
+        </p:nvCxnSpPr>
+        <p:spPr>
+          <a:xfrm>
+            <a:off x="4983480" y="5093207"/>
+            <a:ext cx="137160" cy="0"/>
+          </a:xfrm>
+          <a:prstGeom prst="line">
+            <a:avLst/>
+          </a:prstGeom>
+          <a:ln w="15240">
+            <a:solidFill>
+              <a:srgbClr val="5A6978"/>
+            </a:solidFill>
+          </a:ln>
+        </p:spPr>
+        <p:style>
+          <a:lnRef idx="2">
+            <a:schemeClr val="accent1"/>
+          </a:lnRef>
+          <a:fillRef idx="0">
+            <a:schemeClr val="accent1"/>
+          </a:fillRef>
+          <a:effectRef idx="1">
+            <a:schemeClr val="accent1"/>
+          </a:effectRef>
+          <a:fontRef idx="minor">
+            <a:schemeClr val="tx1"/>
+          </a:fontRef>
+        </p:style>
+      </p:cxnSp>
+      <p:sp>
+        <p:nvSpPr>
+          <p:cNvPr id="63" name="Rectangle 62"/>
+          <p:cNvSpPr/>
+          <p:nvPr/>
+        </p:nvSpPr>
+        <p:spPr>
+          <a:xfrm>
+            <a:off x="5120640" y="4892040"/>
+            <a:ext cx="960120" cy="402336"/>
+          </a:xfrm>
+          <a:prstGeom prst="rect">
+            <a:avLst/>
+          </a:prstGeom>
+          <a:solidFill>
+            <a:srgbClr val="FEEBA9"/>
+          </a:solidFill>
+          <a:ln w="15240">
+            <a:solidFill>
+              <a:srgbClr val="DAAF37"/>
+            </a:solidFill>
+          </a:ln>
+        </p:spPr>
+        <p:style>
+          <a:lnRef idx="1">
+            <a:schemeClr val="accent1"/>
+          </a:lnRef>
+          <a:fillRef idx="3">
+            <a:schemeClr val="accent1"/>
+          </a:fillRef>
+          <a:effectRef idx="2">
+            <a:schemeClr val="accent1"/>
+          </a:effectRef>
+          <a:fontRef idx="minor">
+            <a:schemeClr val="lt1"/>
+          </a:fontRef>
+        </p:style>
+        <p:txBody>
+          <a:bodyPr rtlCol="0" anchor="ctr" wrap="square"/>
+          <a:lstStyle/>
+          <a:p>
+            <a:pPr algn="ctr">
+              <a:defRPr sz="750" b="1">
+                <a:solidFill>
+                  <a:srgbClr val="1E293B"/>
+                </a:solidFill>
+                <a:latin typeface="Arial"/>
+              </a:defRPr>
+            </a:pPr>
+            <a:r>
+              <a:t>Priority Decision</a:t>
+            </a:r>
+          </a:p>
+        </p:txBody>
+      </p:sp>
+      <p:sp>
+        <p:nvSpPr>
+          <p:cNvPr id="64" name="Rounded Rectangle 63"/>
+          <p:cNvSpPr/>
+          <p:nvPr/>
+        </p:nvSpPr>
+        <p:spPr>
+          <a:xfrm>
+            <a:off x="6245352" y="4892040"/>
+            <a:ext cx="1051560" cy="402336"/>
+          </a:xfrm>
+          <a:prstGeom prst="roundRect">
+            <a:avLst/>
+          </a:prstGeom>
+          <a:solidFill>
+            <a:srgbClr val="C8F5A0"/>
+          </a:solidFill>
+          <a:ln w="15240">
+            <a:solidFill>
+              <a:srgbClr val="64B43C"/>
+            </a:solidFill>
+          </a:ln>
+        </p:spPr>
+        <p:style>
+          <a:lnRef idx="1">
+            <a:schemeClr val="accent1"/>
+          </a:lnRef>
+          <a:fillRef idx="3">
+            <a:schemeClr val="accent1"/>
+          </a:fillRef>
+          <a:effectRef idx="2">
+            <a:schemeClr val="accent1"/>
+          </a:effectRef>
+          <a:fontRef idx="minor">
+            <a:schemeClr val="lt1"/>
+          </a:fontRef>
+        </p:style>
+        <p:txBody>
+          <a:bodyPr rtlCol="0" anchor="ctr" wrap="square"/>
+          <a:lstStyle/>
+          <a:p>
+            <a:pPr algn="ctr">
+              <a:defRPr sz="750" b="1">
+                <a:solidFill>
+                  <a:srgbClr val="1E293B"/>
+                </a:solidFill>
+                <a:latin typeface="Arial"/>
+              </a:defRPr>
+            </a:pPr>
+            <a:r>
+              <a:t>Section 161 CrPC</a:t>
+            </a:r>
+          </a:p>
+        </p:txBody>
+      </p:sp>
+      <p:cxnSp>
+        <p:nvCxnSpPr>
+          <p:cNvPr id="65" name="Connector 64"/>
+          <p:cNvCxnSpPr/>
+          <p:nvPr/>
+        </p:nvCxnSpPr>
+        <p:spPr>
+          <a:xfrm>
+            <a:off x="6080760" y="5093207"/>
+            <a:ext cx="164592" cy="0"/>
+          </a:xfrm>
+          <a:prstGeom prst="line">
+            <a:avLst/>
+          </a:prstGeom>
+          <a:ln w="15240">
+            <a:solidFill>
+              <a:srgbClr val="5A6978"/>
+            </a:solidFill>
+          </a:ln>
+        </p:spPr>
+        <p:style>
+          <a:lnRef idx="2">
+            <a:schemeClr val="accent1"/>
+          </a:lnRef>
+          <a:fillRef idx="0">
+            <a:schemeClr val="accent1"/>
+          </a:fillRef>
+          <a:effectRef idx="1">
+            <a:schemeClr val="accent1"/>
+          </a:effectRef>
+          <a:fontRef idx="minor">
+            <a:schemeClr val="tx1"/>
+          </a:fontRef>
+        </p:style>
+      </p:cxnSp>
+      <p:sp>
+        <p:nvSpPr>
+          <p:cNvPr id="66" name="Rounded Rectangle 65"/>
+          <p:cNvSpPr/>
+          <p:nvPr/>
+        </p:nvSpPr>
+        <p:spPr>
+          <a:xfrm>
+            <a:off x="7461504" y="4892040"/>
+            <a:ext cx="1005840" cy="402336"/>
+          </a:xfrm>
+          <a:prstGeom prst="roundRect">
+            <a:avLst/>
+          </a:prstGeom>
+          <a:solidFill>
+            <a:srgbClr val="F5AFA0"/>
+          </a:solidFill>
+          <a:ln w="15240">
+            <a:solidFill>
+              <a:srgbClr val="D26E5A"/>
+            </a:solidFill>
+          </a:ln>
+        </p:spPr>
+        <p:style>
+          <a:lnRef idx="1">
+            <a:schemeClr val="accent1"/>
+          </a:lnRef>
+          <a:fillRef idx="3">
+            <a:schemeClr val="accent1"/>
+          </a:fillRef>
+          <a:effectRef idx="2">
+            <a:schemeClr val="accent1"/>
+          </a:effectRef>
+          <a:fontRef idx="minor">
+            <a:schemeClr val="lt1"/>
+          </a:fontRef>
+        </p:style>
+        <p:txBody>
+          <a:bodyPr rtlCol="0" anchor="ctr" wrap="square"/>
+          <a:lstStyle/>
+          <a:p>
+            <a:pPr algn="ctr">
+              <a:defRPr sz="750" b="1">
+                <a:solidFill>
+                  <a:srgbClr val="1E293B"/>
+                </a:solidFill>
+                <a:latin typeface="Arial"/>
+              </a:defRPr>
+            </a:pPr>
+            <a:r>
+              <a:t>Non-Leading Qs</a:t>
+            </a:r>
+          </a:p>
+        </p:txBody>
+      </p:sp>
+      <p:cxnSp>
+        <p:nvCxnSpPr>
+          <p:cNvPr id="67" name="Connector 66"/>
+          <p:cNvCxnSpPr/>
+          <p:nvPr/>
+        </p:nvCxnSpPr>
+        <p:spPr>
+          <a:xfrm>
+            <a:off x="7296912" y="5093207"/>
+            <a:ext cx="164592" cy="0"/>
+          </a:xfrm>
+          <a:prstGeom prst="line">
+            <a:avLst/>
+          </a:prstGeom>
+          <a:ln w="15240">
+            <a:solidFill>
+              <a:srgbClr val="5A6978"/>
+            </a:solidFill>
+          </a:ln>
+        </p:spPr>
+        <p:style>
+          <a:lnRef idx="2">
+            <a:schemeClr val="accent1"/>
+          </a:lnRef>
+          <a:fillRef idx="0">
+            <a:schemeClr val="accent1"/>
+          </a:fillRef>
+          <a:effectRef idx="1">
+            <a:schemeClr val="accent1"/>
+          </a:effectRef>
+          <a:fontRef idx="minor">
+            <a:schemeClr val="tx1"/>
+          </a:fontRef>
+        </p:style>
+      </p:cxnSp>
+      <p:sp>
+        <p:nvSpPr>
+          <p:cNvPr id="68" name="Rounded Rectangle 67"/>
+          <p:cNvSpPr/>
+          <p:nvPr/>
+        </p:nvSpPr>
+        <p:spPr>
+          <a:xfrm>
+            <a:off x="8631936" y="4892040"/>
+            <a:ext cx="1005840" cy="402336"/>
+          </a:xfrm>
+          <a:prstGeom prst="roundRect">
+            <a:avLst/>
+          </a:prstGeom>
+          <a:solidFill>
+            <a:srgbClr val="C8AFE1"/>
+          </a:solidFill>
+          <a:ln w="15240">
+            <a:solidFill>
+              <a:srgbClr val="8C64B4"/>
+            </a:solidFill>
+          </a:ln>
+        </p:spPr>
+        <p:style>
+          <a:lnRef idx="1">
+            <a:schemeClr val="accent1"/>
+          </a:lnRef>
+          <a:fillRef idx="3">
+            <a:schemeClr val="accent1"/>
+          </a:fillRef>
+          <a:effectRef idx="2">
+            <a:schemeClr val="accent1"/>
+          </a:effectRef>
+          <a:fontRef idx="minor">
+            <a:schemeClr val="lt1"/>
+          </a:fontRef>
+        </p:style>
+        <p:txBody>
+          <a:bodyPr rtlCol="0" anchor="ctr" wrap="square"/>
+          <a:lstStyle/>
+          <a:p>
+            <a:pPr algn="ctr">
+              <a:defRPr sz="750" b="1">
+                <a:solidFill>
+                  <a:srgbClr val="1E293B"/>
+                </a:solidFill>
+                <a:latin typeface="Arial"/>
+              </a:defRPr>
+            </a:pPr>
+            <a:r>
+              <a:t>Court Dossier</a:t>
+            </a:r>
+          </a:p>
+        </p:txBody>
+      </p:sp>
+      <p:cxnSp>
+        <p:nvCxnSpPr>
+          <p:cNvPr id="69" name="Connector 68"/>
+          <p:cNvCxnSpPr/>
+          <p:nvPr/>
+        </p:nvCxnSpPr>
+        <p:spPr>
+          <a:xfrm>
+            <a:off x="8467344" y="5093207"/>
+            <a:ext cx="164592" cy="0"/>
+          </a:xfrm>
+          <a:prstGeom prst="line">
+            <a:avLst/>
+          </a:prstGeom>
+          <a:ln w="15240">
+            <a:solidFill>
+              <a:srgbClr val="5A6978"/>
+            </a:solidFill>
+          </a:ln>
+        </p:spPr>
+        <p:style>
+          <a:lnRef idx="2">
+            <a:schemeClr val="accent1"/>
+          </a:lnRef>
+          <a:fillRef idx="0">
+            <a:schemeClr val="accent1"/>
+          </a:fillRef>
+          <a:effectRef idx="1">
+            <a:schemeClr val="accent1"/>
+          </a:effectRef>
+          <a:fontRef idx="minor">
+            <a:schemeClr val="tx1"/>
+          </a:fontRef>
+        </p:style>
+      </p:cxnSp>
+      <p:cxnSp>
+        <p:nvCxnSpPr>
+          <p:cNvPr id="70" name="Connector 69"/>
+          <p:cNvCxnSpPr/>
+          <p:nvPr/>
+        </p:nvCxnSpPr>
+        <p:spPr>
+          <a:xfrm>
+            <a:off x="4983480" y="5824728"/>
+            <a:ext cx="137160" cy="0"/>
+          </a:xfrm>
+          <a:prstGeom prst="line">
+            <a:avLst/>
+          </a:prstGeom>
+          <a:ln w="15240">
+            <a:solidFill>
+              <a:srgbClr val="5A6978"/>
+            </a:solidFill>
+          </a:ln>
+        </p:spPr>
+        <p:style>
+          <a:lnRef idx="2">
+            <a:schemeClr val="accent1"/>
+          </a:lnRef>
+          <a:fillRef idx="0">
+            <a:schemeClr val="accent1"/>
+          </a:fillRef>
+          <a:effectRef idx="1">
+            <a:schemeClr val="accent1"/>
+          </a:effectRef>
+          <a:fontRef idx="minor">
+            <a:schemeClr val="tx1"/>
+          </a:fontRef>
+        </p:style>
+      </p:cxnSp>
+      <p:sp>
+        <p:nvSpPr>
+          <p:cNvPr id="71" name="Rectangle 70"/>
+          <p:cNvSpPr/>
+          <p:nvPr/>
+        </p:nvSpPr>
+        <p:spPr>
+          <a:xfrm>
+            <a:off x="5120640" y="5623560"/>
+            <a:ext cx="960120" cy="402336"/>
+          </a:xfrm>
+          <a:prstGeom prst="rect">
+            <a:avLst/>
+          </a:prstGeom>
+          <a:solidFill>
+            <a:srgbClr val="FEEBA9"/>
+          </a:solidFill>
+          <a:ln w="15240">
+            <a:solidFill>
+              <a:srgbClr val="DAAF37"/>
+            </a:solidFill>
+          </a:ln>
+        </p:spPr>
+        <p:style>
+          <a:lnRef idx="1">
+            <a:schemeClr val="accent1"/>
+          </a:lnRef>
+          <a:fillRef idx="3">
+            <a:schemeClr val="accent1"/>
+          </a:fillRef>
+          <a:effectRef idx="2">
+            <a:schemeClr val="accent1"/>
+          </a:effectRef>
+          <a:fontRef idx="minor">
+            <a:schemeClr val="lt1"/>
+          </a:fontRef>
+        </p:style>
+        <p:txBody>
+          <a:bodyPr rtlCol="0" anchor="ctr" wrap="square"/>
+          <a:lstStyle/>
+          <a:p>
+            <a:pPr algn="ctr">
+              <a:defRPr sz="750" b="1">
+                <a:solidFill>
+                  <a:srgbClr val="1E293B"/>
+                </a:solidFill>
+                <a:latin typeface="Arial"/>
+              </a:defRPr>
+            </a:pPr>
+            <a:r>
+              <a:t>Investigator HUD</a:t>
+            </a:r>
+          </a:p>
+        </p:txBody>
+      </p:sp>
+      <p:sp>
+        <p:nvSpPr>
+          <p:cNvPr id="72" name="Rounded Rectangle 71"/>
+          <p:cNvSpPr/>
+          <p:nvPr/>
+        </p:nvSpPr>
+        <p:spPr>
+          <a:xfrm>
+            <a:off x="6245352" y="5623560"/>
+            <a:ext cx="1188720" cy="402336"/>
+          </a:xfrm>
+          <a:prstGeom prst="roundRect">
+            <a:avLst/>
+          </a:prstGeom>
+          <a:solidFill>
+            <a:srgbClr val="C8F5A0"/>
+          </a:solidFill>
+          <a:ln w="15240">
+            <a:solidFill>
+              <a:srgbClr val="64B43C"/>
+            </a:solidFill>
+          </a:ln>
+        </p:spPr>
+        <p:style>
+          <a:lnRef idx="1">
+            <a:schemeClr val="accent1"/>
+          </a:lnRef>
+          <a:fillRef idx="3">
+            <a:schemeClr val="accent1"/>
+          </a:fillRef>
+          <a:effectRef idx="2">
+            <a:schemeClr val="accent1"/>
+          </a:effectRef>
+          <a:fontRef idx="minor">
+            <a:schemeClr val="lt1"/>
+          </a:fontRef>
+        </p:style>
+        <p:txBody>
+          <a:bodyPr rtlCol="0" anchor="ctr" wrap="square"/>
+          <a:lstStyle/>
+          <a:p>
+            <a:pPr algn="ctr">
+              <a:defRPr sz="750" b="1">
+                <a:solidFill>
+                  <a:srgbClr val="1E293B"/>
+                </a:solidFill>
+                <a:latin typeface="Arial"/>
+              </a:defRPr>
+            </a:pPr>
+            <a:r>
+              <a:t>2D/3D WebGL Canvas</a:t>
+            </a:r>
+          </a:p>
+        </p:txBody>
+      </p:sp>
+      <p:cxnSp>
+        <p:nvCxnSpPr>
+          <p:cNvPr id="73" name="Connector 72"/>
+          <p:cNvCxnSpPr/>
+          <p:nvPr/>
+        </p:nvCxnSpPr>
+        <p:spPr>
+          <a:xfrm>
+            <a:off x="6080760" y="5824728"/>
+            <a:ext cx="164592" cy="0"/>
+          </a:xfrm>
+          <a:prstGeom prst="line">
+            <a:avLst/>
+          </a:prstGeom>
+          <a:ln w="15240">
+            <a:solidFill>
+              <a:srgbClr val="5A6978"/>
+            </a:solidFill>
+          </a:ln>
+        </p:spPr>
+        <p:style>
+          <a:lnRef idx="2">
+            <a:schemeClr val="accent1"/>
+          </a:lnRef>
+          <a:fillRef idx="0">
+            <a:schemeClr val="accent1"/>
+          </a:fillRef>
+          <a:effectRef idx="1">
+            <a:schemeClr val="accent1"/>
+          </a:effectRef>
+          <a:fontRef idx="minor">
+            <a:schemeClr val="tx1"/>
+          </a:fontRef>
+        </p:style>
+      </p:cxnSp>
+      <p:sp>
+        <p:nvSpPr>
+          <p:cNvPr id="74" name="Rounded Rectangle 73"/>
+          <p:cNvSpPr/>
+          <p:nvPr/>
+        </p:nvSpPr>
+        <p:spPr>
+          <a:xfrm>
+            <a:off x="7598664" y="5623560"/>
+            <a:ext cx="1051560" cy="402336"/>
+          </a:xfrm>
+          <a:prstGeom prst="roundRect">
+            <a:avLst/>
+          </a:prstGeom>
+          <a:solidFill>
+            <a:srgbClr val="99E6F2"/>
+          </a:solidFill>
+          <a:ln w="15240">
+            <a:solidFill>
+              <a:srgbClr val="00A0BE"/>
+            </a:solidFill>
+          </a:ln>
+        </p:spPr>
+        <p:style>
+          <a:lnRef idx="1">
+            <a:schemeClr val="accent1"/>
+          </a:lnRef>
+          <a:fillRef idx="3">
+            <a:schemeClr val="accent1"/>
+          </a:fillRef>
+          <a:effectRef idx="2">
+            <a:schemeClr val="accent1"/>
+          </a:effectRef>
+          <a:fontRef idx="minor">
+            <a:schemeClr val="lt1"/>
+          </a:fontRef>
+        </p:style>
+        <p:txBody>
+          <a:bodyPr rtlCol="0" anchor="ctr" wrap="square"/>
+          <a:lstStyle/>
+          <a:p>
+            <a:pPr algn="ctr">
+              <a:defRPr sz="750" b="1">
+                <a:solidFill>
+                  <a:srgbClr val="1E293B"/>
+                </a:solidFill>
+                <a:latin typeface="Arial"/>
+              </a:defRPr>
+            </a:pPr>
+            <a:r>
+              <a:t>Timeline Replay</a:t>
+            </a:r>
+          </a:p>
+        </p:txBody>
+      </p:sp>
+      <p:cxnSp>
+        <p:nvCxnSpPr>
+          <p:cNvPr id="75" name="Connector 74"/>
+          <p:cNvCxnSpPr/>
+          <p:nvPr/>
+        </p:nvCxnSpPr>
+        <p:spPr>
+          <a:xfrm>
+            <a:off x="7434072" y="5824728"/>
+            <a:ext cx="164592" cy="0"/>
+          </a:xfrm>
+          <a:prstGeom prst="line">
+            <a:avLst/>
+          </a:prstGeom>
+          <a:ln w="15240">
+            <a:solidFill>
+              <a:srgbClr val="5A6978"/>
+            </a:solidFill>
+          </a:ln>
+        </p:spPr>
+        <p:style>
+          <a:lnRef idx="2">
+            <a:schemeClr val="accent1"/>
+          </a:lnRef>
+          <a:fillRef idx="0">
+            <a:schemeClr val="accent1"/>
+          </a:fillRef>
+          <a:effectRef idx="1">
+            <a:schemeClr val="accent1"/>
+          </a:effectRef>
+          <a:fontRef idx="minor">
+            <a:schemeClr val="tx1"/>
+          </a:fontRef>
+        </p:style>
+      </p:cxnSp>
+      <p:sp>
+        <p:nvSpPr>
+          <p:cNvPr id="76" name="Rounded Rectangle 75"/>
+          <p:cNvSpPr/>
+          <p:nvPr/>
+        </p:nvSpPr>
+        <p:spPr>
+          <a:xfrm>
+            <a:off x="8814816" y="5623560"/>
+            <a:ext cx="960120" cy="402336"/>
+          </a:xfrm>
+          <a:prstGeom prst="roundRect">
+            <a:avLst/>
+          </a:prstGeom>
+          <a:solidFill>
+            <a:srgbClr val="C8AFE1"/>
+          </a:solidFill>
+          <a:ln w="15240">
+            <a:solidFill>
+              <a:srgbClr val="8C64B4"/>
+            </a:solidFill>
+          </a:ln>
+        </p:spPr>
+        <p:style>
+          <a:lnRef idx="1">
+            <a:schemeClr val="accent1"/>
+          </a:lnRef>
+          <a:fillRef idx="3">
+            <a:schemeClr val="accent1"/>
+          </a:fillRef>
+          <a:effectRef idx="2">
+            <a:schemeClr val="accent1"/>
+          </a:effectRef>
+          <a:fontRef idx="minor">
+            <a:schemeClr val="lt1"/>
+          </a:fontRef>
+        </p:style>
+        <p:txBody>
+          <a:bodyPr rtlCol="0" anchor="ctr" wrap="square"/>
+          <a:lstStyle/>
+          <a:p>
+            <a:pPr algn="ctr">
+              <a:defRPr sz="750" b="1">
+                <a:solidFill>
+                  <a:srgbClr val="1E293B"/>
+                </a:solidFill>
+                <a:latin typeface="Arial"/>
+              </a:defRPr>
+            </a:pPr>
+            <a:r>
+              <a:t>Export Dossier</a:t>
+            </a:r>
+          </a:p>
+        </p:txBody>
+      </p:sp>
+      <p:cxnSp>
+        <p:nvCxnSpPr>
+          <p:cNvPr id="77" name="Connector 76"/>
+          <p:cNvCxnSpPr/>
+          <p:nvPr/>
+        </p:nvCxnSpPr>
+        <p:spPr>
+          <a:xfrm>
+            <a:off x="8650224" y="5824728"/>
+            <a:ext cx="164592" cy="0"/>
+          </a:xfrm>
+          <a:prstGeom prst="line">
+            <a:avLst/>
+          </a:prstGeom>
+          <a:ln w="15240">
+            <a:solidFill>
+              <a:srgbClr val="5A6978"/>
+            </a:solidFill>
+          </a:ln>
+        </p:spPr>
+        <p:style>
+          <a:lnRef idx="2">
+            <a:schemeClr val="accent1"/>
+          </a:lnRef>
+          <a:fillRef idx="0">
+            <a:schemeClr val="accent1"/>
+          </a:fillRef>
+          <a:effectRef idx="1">
+            <a:schemeClr val="accent1"/>
+          </a:effectRef>
+          <a:fontRef idx="minor">
+            <a:schemeClr val="tx1"/>
+          </a:fontRef>
+        </p:style>
+      </p:cxnSp>
+      <p:sp>
+        <p:nvSpPr>
+          <p:cNvPr id="78" name="Rounded Rectangle 77"/>
+          <p:cNvSpPr/>
+          <p:nvPr/>
+        </p:nvSpPr>
+        <p:spPr>
+          <a:xfrm>
+            <a:off x="9692640" y="1097280"/>
+            <a:ext cx="2057400" cy="5074920"/>
+          </a:xfrm>
+          <a:prstGeom prst="roundRect">
+            <a:avLst/>
+          </a:prstGeom>
+          <a:solidFill>
+            <a:srgbClr val="F8FAFC"/>
+          </a:solidFill>
+          <a:ln w="19050">
+            <a:solidFill>
+              <a:srgbClr val="CBD5E1"/>
+            </a:solidFill>
+          </a:ln>
+        </p:spPr>
+        <p:style>
+          <a:lnRef idx="1">
+            <a:schemeClr val="accent1"/>
+          </a:lnRef>
+          <a:fillRef idx="3">
+            <a:schemeClr val="accent1"/>
+          </a:fillRef>
+          <a:effectRef idx="2">
+            <a:schemeClr val="accent1"/>
+          </a:effectRef>
+          <a:fontRef idx="minor">
+            <a:schemeClr val="lt1"/>
+          </a:fontRef>
+        </p:style>
+        <p:txBody>
+          <a:bodyPr rtlCol="0" anchor="ctr"/>
+          <a:lstStyle/>
+          <a:p>
+            <a:pPr algn="ctr">
+              <a:defRPr sz="1200" b="1">
+                <a:solidFill>
+                  <a:srgbClr val="0F2942"/>
+                </a:solidFill>
+              </a:defRPr>
+            </a:pPr>
+            <a:r>
+              <a:t>TOOL STACK</a:t>
+            </a:r>
+          </a:p>
+        </p:txBody>
+      </p:sp>
+      <p:sp>
+        <p:nvSpPr>
+          <p:cNvPr id="79" name="Rounded Rectangle 78"/>
+          <p:cNvSpPr/>
+          <p:nvPr/>
+        </p:nvSpPr>
+        <p:spPr>
+          <a:xfrm>
+            <a:off x="9829800" y="1508760"/>
+            <a:ext cx="1783080" cy="384048"/>
+          </a:xfrm>
+          <a:prstGeom prst="roundRect">
+            <a:avLst/>
+          </a:prstGeom>
+          <a:solidFill>
+            <a:srgbClr val="EBF5FF"/>
+          </a:solidFill>
+          <a:ln w="12700">
+            <a:solidFill>
+              <a:srgbClr val="3572A5"/>
+            </a:solidFill>
+          </a:ln>
+        </p:spPr>
+        <p:style>
+          <a:lnRef idx="1">
+            <a:schemeClr val="accent1"/>
+          </a:lnRef>
+          <a:fillRef idx="3">
+            <a:schemeClr val="accent1"/>
+          </a:fillRef>
+          <a:effectRef idx="2">
+            <a:schemeClr val="accent1"/>
+          </a:effectRef>
+          <a:fontRef idx="minor">
+            <a:schemeClr val="lt1"/>
+          </a:fontRef>
+        </p:style>
+        <p:txBody>
+          <a:bodyPr rtlCol="0" anchor="ctr"/>
+          <a:lstStyle/>
+          <a:p>
+            <a:pPr algn="ctr">
+              <a:defRPr sz="900" b="1">
+                <a:solidFill>
+                  <a:srgbClr val="3572A5"/>
+                </a:solidFill>
+              </a:defRPr>
+            </a:pPr>
+            <a:r>
+              <a:t>⚙ Python 3.13</a:t>
+            </a:r>
+          </a:p>
+        </p:txBody>
+      </p:sp>
+      <p:sp>
+        <p:nvSpPr>
+          <p:cNvPr id="80" name="Rounded Rectangle 79"/>
+          <p:cNvSpPr/>
+          <p:nvPr/>
+        </p:nvSpPr>
+        <p:spPr>
+          <a:xfrm>
+            <a:off x="9829800" y="1956816"/>
+            <a:ext cx="1783080" cy="384048"/>
+          </a:xfrm>
+          <a:prstGeom prst="roundRect">
+            <a:avLst/>
+          </a:prstGeom>
+          <a:solidFill>
+            <a:srgbClr val="ECFDF5"/>
+          </a:solidFill>
+          <a:ln w="12700">
+            <a:solidFill>
+              <a:srgbClr val="059669"/>
+            </a:solidFill>
+          </a:ln>
+        </p:spPr>
+        <p:style>
+          <a:lnRef idx="1">
+            <a:schemeClr val="accent1"/>
+          </a:lnRef>
+          <a:fillRef idx="3">
+            <a:schemeClr val="accent1"/>
+          </a:fillRef>
+          <a:effectRef idx="2">
+            <a:schemeClr val="accent1"/>
+          </a:effectRef>
+          <a:fontRef idx="minor">
+            <a:schemeClr val="lt1"/>
+          </a:fontRef>
+        </p:style>
+        <p:txBody>
+          <a:bodyPr rtlCol="0" anchor="ctr"/>
+          <a:lstStyle/>
+          <a:p>
+            <a:pPr algn="ctr">
+              <a:defRPr sz="900" b="1">
+                <a:solidFill>
+                  <a:srgbClr val="059669"/>
+                </a:solidFill>
+              </a:defRPr>
+            </a:pPr>
+            <a:r>
+              <a:t>⚙ FastAPI</a:t>
+            </a:r>
+          </a:p>
+        </p:txBody>
+      </p:sp>
+      <p:sp>
+        <p:nvSpPr>
+          <p:cNvPr id="81" name="Rounded Rectangle 80"/>
+          <p:cNvSpPr/>
+          <p:nvPr/>
+        </p:nvSpPr>
+        <p:spPr>
+          <a:xfrm>
+            <a:off x="9829800" y="2404872"/>
+            <a:ext cx="1783080" cy="384048"/>
+          </a:xfrm>
+          <a:prstGeom prst="roundRect">
+            <a:avLst/>
+          </a:prstGeom>
+          <a:solidFill>
+            <a:srgbClr val="EFF6FF"/>
+          </a:solidFill>
+          <a:ln w="12700">
+            <a:solidFill>
+              <a:srgbClr val="1E40AF"/>
+            </a:solidFill>
+          </a:ln>
+        </p:spPr>
+        <p:style>
+          <a:lnRef idx="1">
+            <a:schemeClr val="accent1"/>
+          </a:lnRef>
+          <a:fillRef idx="3">
+            <a:schemeClr val="accent1"/>
+          </a:fillRef>
+          <a:effectRef idx="2">
+            <a:schemeClr val="accent1"/>
+          </a:effectRef>
+          <a:fontRef idx="minor">
+            <a:schemeClr val="lt1"/>
+          </a:fontRef>
+        </p:style>
+        <p:txBody>
+          <a:bodyPr rtlCol="0" anchor="ctr"/>
+          <a:lstStyle/>
+          <a:p>
+            <a:pPr algn="ctr">
+              <a:defRPr sz="900" b="1">
+                <a:solidFill>
+                  <a:srgbClr val="1E40AF"/>
+                </a:solidFill>
+              </a:defRPr>
+            </a:pPr>
+            <a:r>
+              <a:t>⚙ NetworkX</a:t>
+            </a:r>
+          </a:p>
+        </p:txBody>
+      </p:sp>
+      <p:sp>
+        <p:nvSpPr>
+          <p:cNvPr id="82" name="Rounded Rectangle 81"/>
+          <p:cNvSpPr/>
+          <p:nvPr/>
+        </p:nvSpPr>
+        <p:spPr>
+          <a:xfrm>
+            <a:off x="9829800" y="2852928"/>
+            <a:ext cx="1783080" cy="384048"/>
+          </a:xfrm>
+          <a:prstGeom prst="roundRect">
+            <a:avLst/>
+          </a:prstGeom>
+          <a:solidFill>
+            <a:srgbClr val="FEF3C7"/>
+          </a:solidFill>
+          <a:ln w="12700">
+            <a:solidFill>
+              <a:srgbClr val="D97706"/>
+            </a:solidFill>
+          </a:ln>
+        </p:spPr>
+        <p:style>
+          <a:lnRef idx="1">
+            <a:schemeClr val="accent1"/>
+          </a:lnRef>
+          <a:fillRef idx="3">
+            <a:schemeClr val="accent1"/>
+          </a:fillRef>
+          <a:effectRef idx="2">
+            <a:schemeClr val="accent1"/>
+          </a:effectRef>
+          <a:fontRef idx="minor">
+            <a:schemeClr val="lt1"/>
+          </a:fontRef>
+        </p:style>
+        <p:txBody>
+          <a:bodyPr rtlCol="0" anchor="ctr"/>
+          <a:lstStyle/>
+          <a:p>
+            <a:pPr algn="ctr">
+              <a:defRPr sz="900" b="1">
+                <a:solidFill>
+                  <a:srgbClr val="D97706"/>
+                </a:solidFill>
+              </a:defRPr>
+            </a:pPr>
+            <a:r>
+              <a:t>⚙ Scikit-Learn</a:t>
+            </a:r>
+          </a:p>
+        </p:txBody>
+      </p:sp>
+      <p:sp>
+        <p:nvSpPr>
+          <p:cNvPr id="83" name="Rounded Rectangle 82"/>
+          <p:cNvSpPr/>
+          <p:nvPr/>
+        </p:nvSpPr>
+        <p:spPr>
+          <a:xfrm>
+            <a:off x="9829800" y="3300984"/>
+            <a:ext cx="1783080" cy="384048"/>
+          </a:xfrm>
+          <a:prstGeom prst="roundRect">
+            <a:avLst/>
+          </a:prstGeom>
+          <a:solidFill>
+            <a:srgbClr val="ECFEFF"/>
+          </a:solidFill>
+          <a:ln w="12700">
+            <a:solidFill>
+              <a:srgbClr val="0891B2"/>
+            </a:solidFill>
+          </a:ln>
+        </p:spPr>
+        <p:style>
+          <a:lnRef idx="1">
+            <a:schemeClr val="accent1"/>
+          </a:lnRef>
+          <a:fillRef idx="3">
+            <a:schemeClr val="accent1"/>
+          </a:fillRef>
+          <a:effectRef idx="2">
+            <a:schemeClr val="accent1"/>
+          </a:effectRef>
+          <a:fontRef idx="minor">
+            <a:schemeClr val="lt1"/>
+          </a:fontRef>
+        </p:style>
+        <p:txBody>
+          <a:bodyPr rtlCol="0" anchor="ctr"/>
+          <a:lstStyle/>
+          <a:p>
+            <a:pPr algn="ctr">
+              <a:defRPr sz="900" b="1">
+                <a:solidFill>
+                  <a:srgbClr val="0891B2"/>
+                </a:solidFill>
+              </a:defRPr>
+            </a:pPr>
+            <a:r>
+              <a:t>⚙ React 18 + TS</a:t>
+            </a:r>
+          </a:p>
+        </p:txBody>
+      </p:sp>
+      <p:sp>
+        <p:nvSpPr>
+          <p:cNvPr id="84" name="Rounded Rectangle 83"/>
+          <p:cNvSpPr/>
+          <p:nvPr/>
+        </p:nvSpPr>
+        <p:spPr>
+          <a:xfrm>
+            <a:off x="9829800" y="3749040"/>
+            <a:ext cx="1783080" cy="384048"/>
+          </a:xfrm>
+          <a:prstGeom prst="roundRect">
+            <a:avLst/>
+          </a:prstGeom>
+          <a:solidFill>
+            <a:srgbClr val="F1F5F9"/>
+          </a:solidFill>
+          <a:ln w="12700">
+            <a:solidFill>
+              <a:srgbClr val="0F172A"/>
+            </a:solidFill>
+          </a:ln>
+        </p:spPr>
+        <p:style>
+          <a:lnRef idx="1">
+            <a:schemeClr val="accent1"/>
+          </a:lnRef>
+          <a:fillRef idx="3">
+            <a:schemeClr val="accent1"/>
+          </a:fillRef>
+          <a:effectRef idx="2">
+            <a:schemeClr val="accent1"/>
+          </a:effectRef>
+          <a:fontRef idx="minor">
+            <a:schemeClr val="lt1"/>
+          </a:fontRef>
+        </p:style>
+        <p:txBody>
+          <a:bodyPr rtlCol="0" anchor="ctr"/>
+          <a:lstStyle/>
+          <a:p>
+            <a:pPr algn="ctr">
+              <a:defRPr sz="900" b="1">
+                <a:solidFill>
+                  <a:srgbClr val="0F172A"/>
+                </a:solidFill>
+              </a:defRPr>
+            </a:pPr>
+            <a:r>
+              <a:t>⚙ Three.js WebGL</a:t>
+            </a:r>
+          </a:p>
+        </p:txBody>
+      </p:sp>
+      <p:sp>
+        <p:nvSpPr>
+          <p:cNvPr id="85" name="Rounded Rectangle 84"/>
+          <p:cNvSpPr/>
+          <p:nvPr/>
+        </p:nvSpPr>
+        <p:spPr>
+          <a:xfrm>
+            <a:off x="9829800" y="4197096"/>
+            <a:ext cx="1783080" cy="384048"/>
+          </a:xfrm>
+          <a:prstGeom prst="roundRect">
+            <a:avLst/>
+          </a:prstGeom>
+          <a:solidFill>
+            <a:srgbClr val="F0F9FF"/>
+          </a:solidFill>
+          <a:ln w="12700">
+            <a:solidFill>
+              <a:srgbClr val="0EA5E9"/>
+            </a:solidFill>
+          </a:ln>
+        </p:spPr>
+        <p:style>
+          <a:lnRef idx="1">
+            <a:schemeClr val="accent1"/>
+          </a:lnRef>
+          <a:fillRef idx="3">
+            <a:schemeClr val="accent1"/>
+          </a:fillRef>
+          <a:effectRef idx="2">
+            <a:schemeClr val="accent1"/>
+          </a:effectRef>
+          <a:fontRef idx="minor">
+            <a:schemeClr val="lt1"/>
+          </a:fontRef>
+        </p:style>
+        <p:txBody>
+          <a:bodyPr rtlCol="0" anchor="ctr"/>
+          <a:lstStyle/>
+          <a:p>
+            <a:pPr algn="ctr">
+              <a:defRPr sz="900" b="1">
+                <a:solidFill>
+                  <a:srgbClr val="0EA5E9"/>
+                </a:solidFill>
+              </a:defRPr>
+            </a:pPr>
+            <a:r>
+              <a:t>⚙ Tailwind CSS</a:t>
+            </a:r>
+          </a:p>
+        </p:txBody>
+      </p:sp>
+      <p:sp>
+        <p:nvSpPr>
+          <p:cNvPr id="86" name="Rounded Rectangle 85"/>
+          <p:cNvSpPr/>
+          <p:nvPr/>
+        </p:nvSpPr>
+        <p:spPr>
+          <a:xfrm>
+            <a:off x="9829800" y="4645152"/>
+            <a:ext cx="1783080" cy="384048"/>
+          </a:xfrm>
+          <a:prstGeom prst="roundRect">
+            <a:avLst/>
+          </a:prstGeom>
+          <a:solidFill>
+            <a:srgbClr val="F8FAFC"/>
+          </a:solidFill>
+          <a:ln w="12700">
+            <a:solidFill>
+              <a:srgbClr val="475569"/>
+            </a:solidFill>
+          </a:ln>
+        </p:spPr>
+        <p:style>
+          <a:lnRef idx="1">
+            <a:schemeClr val="accent1"/>
+          </a:lnRef>
+          <a:fillRef idx="3">
+            <a:schemeClr val="accent1"/>
+          </a:fillRef>
+          <a:effectRef idx="2">
+            <a:schemeClr val="accent1"/>
+          </a:effectRef>
+          <a:fontRef idx="minor">
+            <a:schemeClr val="lt1"/>
+          </a:fontRef>
+        </p:style>
+        <p:txBody>
+          <a:bodyPr rtlCol="0" anchor="ctr"/>
+          <a:lstStyle/>
+          <a:p>
+            <a:pPr algn="ctr">
+              <a:defRPr sz="900" b="1">
+                <a:solidFill>
+                  <a:srgbClr val="475569"/>
+                </a:solidFill>
+              </a:defRPr>
+            </a:pPr>
+            <a:r>
+              <a:t>⚙ SQLite WAL</a:t>
+            </a:r>
+          </a:p>
+        </p:txBody>
+      </p:sp>
+      <p:sp>
+        <p:nvSpPr>
+          <p:cNvPr id="87" name="Rounded Rectangle 86"/>
+          <p:cNvSpPr/>
+          <p:nvPr/>
+        </p:nvSpPr>
+        <p:spPr>
+          <a:xfrm>
+            <a:off x="9829800" y="5093208"/>
+            <a:ext cx="1783080" cy="384048"/>
+          </a:xfrm>
+          <a:prstGeom prst="roundRect">
+            <a:avLst/>
+          </a:prstGeom>
+          <a:solidFill>
+            <a:srgbClr val="FAF5FF"/>
+          </a:solidFill>
+          <a:ln w="12700">
+            <a:solidFill>
+              <a:srgbClr val="A855F7"/>
+            </a:solidFill>
+          </a:ln>
+        </p:spPr>
+        <p:style>
+          <a:lnRef idx="1">
+            <a:schemeClr val="accent1"/>
+          </a:lnRef>
+          <a:fillRef idx="3">
+            <a:schemeClr val="accent1"/>
+          </a:fillRef>
+          <a:effectRef idx="2">
+            <a:schemeClr val="accent1"/>
+          </a:effectRef>
+          <a:fontRef idx="minor">
+            <a:schemeClr val="lt1"/>
+          </a:fontRef>
+        </p:style>
+        <p:txBody>
+          <a:bodyPr rtlCol="0" anchor="ctr"/>
+          <a:lstStyle/>
+          <a:p>
+            <a:pPr algn="ctr">
+              <a:defRPr sz="900" b="1">
+                <a:solidFill>
+                  <a:srgbClr val="A855F7"/>
+                </a:solidFill>
+              </a:defRPr>
+            </a:pPr>
+            <a:r>
+              <a:t>⚙ Pandas &amp; NumPy</a:t>
+            </a:r>
+          </a:p>
+        </p:txBody>
+      </p:sp>
+      <p:sp>
+        <p:nvSpPr>
+          <p:cNvPr id="88" name="Rounded Rectangle 87"/>
+          <p:cNvSpPr/>
+          <p:nvPr/>
+        </p:nvSpPr>
+        <p:spPr>
+          <a:xfrm>
+            <a:off x="9829800" y="5541264"/>
+            <a:ext cx="1783080" cy="384048"/>
+          </a:xfrm>
+          <a:prstGeom prst="roundRect">
+            <a:avLst/>
+          </a:prstGeom>
+          <a:solidFill>
+            <a:srgbClr val="FFF1F2"/>
+          </a:solidFill>
+          <a:ln w="12700">
+            <a:solidFill>
+              <a:srgbClr val="E11D48"/>
+            </a:solidFill>
+          </a:ln>
+        </p:spPr>
+        <p:style>
+          <a:lnRef idx="1">
+            <a:schemeClr val="accent1"/>
+          </a:lnRef>
+          <a:fillRef idx="3">
+            <a:schemeClr val="accent1"/>
+          </a:fillRef>
+          <a:effectRef idx="2">
+            <a:schemeClr val="accent1"/>
+          </a:effectRef>
+          <a:fontRef idx="minor">
+            <a:schemeClr val="lt1"/>
+          </a:fontRef>
+        </p:style>
+        <p:txBody>
+          <a:bodyPr rtlCol="0" anchor="ctr"/>
+          <a:lstStyle/>
+          <a:p>
+            <a:pPr algn="ctr">
+              <a:defRPr sz="900" b="1">
+                <a:solidFill>
+                  <a:srgbClr val="E11D48"/>
+                </a:solidFill>
+              </a:defRPr>
+            </a:pPr>
+            <a:r>
+              <a:t>⚙ PyPDF Extraction</a:t>
+            </a:r>
+          </a:p>
+        </p:txBody>
+      </p:sp>
+      <p:sp>
+        <p:nvSpPr>
+          <p:cNvPr id="89" name="Rounded Rectangle 88"/>
           <p:cNvSpPr/>
           <p:nvPr/>
         </p:nvSpPr>
@@ -4451,795 +8324,6 @@
             </a:pPr>
             <a:r>
               <a:t>@SIH Idea submission        3</a:t>
-            </a:r>
-          </a:p>
-        </p:txBody>
-      </p:sp>
-      <p:sp>
-        <p:nvSpPr>
-          <p:cNvPr id="6" name="Rounded Rectangle 5"/>
-          <p:cNvSpPr/>
-          <p:nvPr/>
-        </p:nvSpPr>
-        <p:spPr>
-          <a:xfrm>
-            <a:off x="548640" y="1188720"/>
-            <a:ext cx="8412480" cy="1115568"/>
-          </a:xfrm>
-          <a:prstGeom prst="roundRect">
-            <a:avLst/>
-          </a:prstGeom>
-          <a:solidFill>
-            <a:srgbClr val="FFFFFF"/>
-          </a:solidFill>
-          <a:ln w="19050">
-            <a:solidFill>
-              <a:srgbClr val="CBD5E1"/>
-            </a:solidFill>
-          </a:ln>
-        </p:spPr>
-        <p:style>
-          <a:lnRef idx="1">
-            <a:schemeClr val="accent1"/>
-          </a:lnRef>
-          <a:fillRef idx="3">
-            <a:schemeClr val="accent1"/>
-          </a:fillRef>
-          <a:effectRef idx="2">
-            <a:schemeClr val="accent1"/>
-          </a:effectRef>
-          <a:fontRef idx="minor">
-            <a:schemeClr val="lt1"/>
-          </a:fontRef>
-        </p:style>
-        <p:txBody>
-          <a:bodyPr rtlCol="0" anchor="ctr" wrap="square"/>
-          <a:lstStyle/>
-          <a:p>
-            <a:pPr algn="ctr">
-              <a:spcAft>
-                <a:spcPts val="200"/>
-              </a:spcAft>
-              <a:defRPr sz="1100" b="1">
-                <a:solidFill>
-                  <a:srgbClr val="0F2942"/>
-                </a:solidFill>
-              </a:defRPr>
-            </a:pPr>
-            <a:r>
-              <a:t>STAGE 1: MULTI-MODAL INGESTION &amp; NORMALIZATION</a:t>
-            </a:r>
-          </a:p>
-          <a:p>
-            <a:pPr>
-              <a:defRPr sz="950">
-                <a:solidFill>
-                  <a:srgbClr val="475569"/>
-                </a:solidFill>
-              </a:defRPr>
-            </a:pPr>
-            <a:r>
-              <a:t>Unstructured FIRs, Scanned PDFs, Telecom CDR CSVs, Bank Ledgers, Wiretap WAV</a:t>
-            </a:r>
-            <a:br/>
-            <a:r>
-              <a:t>• DocumentParser &amp; UniversalETL: Multi-header variant normalization</a:t>
-            </a:r>
-            <a:br/>
-            <a:r>
-              <a:t>• OCRNormalizer: Strips unicode ligatures, zero-width spaces, broken wraps</a:t>
-            </a:r>
-            <a:br/>
-            <a:r>
-              <a:t>• SHA-256 Hashing: Generates cryptographic tamper-proof proof on arrival</a:t>
-            </a:r>
-          </a:p>
-        </p:txBody>
-      </p:sp>
-      <p:sp>
-        <p:nvSpPr>
-          <p:cNvPr id="7" name="Rectangle 6"/>
-          <p:cNvSpPr/>
-          <p:nvPr/>
-        </p:nvSpPr>
-        <p:spPr>
-          <a:xfrm>
-            <a:off x="548640" y="1188720"/>
-            <a:ext cx="137160" cy="1115568"/>
-          </a:xfrm>
-          <a:prstGeom prst="rect">
-            <a:avLst/>
-          </a:prstGeom>
-          <a:solidFill>
-            <a:srgbClr val="109566"/>
-          </a:solidFill>
-          <a:ln>
-            <a:noFill/>
-          </a:ln>
-        </p:spPr>
-        <p:style>
-          <a:lnRef idx="1">
-            <a:schemeClr val="accent1"/>
-          </a:lnRef>
-          <a:fillRef idx="3">
-            <a:schemeClr val="accent1"/>
-          </a:fillRef>
-          <a:effectRef idx="2">
-            <a:schemeClr val="accent1"/>
-          </a:effectRef>
-          <a:fontRef idx="minor">
-            <a:schemeClr val="lt1"/>
-          </a:fontRef>
-        </p:style>
-        <p:txBody>
-          <a:bodyPr rtlCol="0" anchor="ctr"/>
-          <a:lstStyle/>
-          <a:p>
-            <a:pPr algn="ctr"/>
-          </a:p>
-        </p:txBody>
-      </p:sp>
-      <p:sp>
-        <p:nvSpPr>
-          <p:cNvPr id="8" name="Rounded Rectangle 7"/>
-          <p:cNvSpPr/>
-          <p:nvPr/>
-        </p:nvSpPr>
-        <p:spPr>
-          <a:xfrm>
-            <a:off x="548640" y="2423160"/>
-            <a:ext cx="8412480" cy="1115568"/>
-          </a:xfrm>
-          <a:prstGeom prst="roundRect">
-            <a:avLst/>
-          </a:prstGeom>
-          <a:solidFill>
-            <a:srgbClr val="FFFFFF"/>
-          </a:solidFill>
-          <a:ln w="19050">
-            <a:solidFill>
-              <a:srgbClr val="CBD5E1"/>
-            </a:solidFill>
-          </a:ln>
-        </p:spPr>
-        <p:style>
-          <a:lnRef idx="1">
-            <a:schemeClr val="accent1"/>
-          </a:lnRef>
-          <a:fillRef idx="3">
-            <a:schemeClr val="accent1"/>
-          </a:fillRef>
-          <a:effectRef idx="2">
-            <a:schemeClr val="accent1"/>
-          </a:effectRef>
-          <a:fontRef idx="minor">
-            <a:schemeClr val="lt1"/>
-          </a:fontRef>
-        </p:style>
-        <p:txBody>
-          <a:bodyPr rtlCol="0" anchor="ctr" wrap="square"/>
-          <a:lstStyle/>
-          <a:p>
-            <a:pPr algn="ctr">
-              <a:spcAft>
-                <a:spcPts val="200"/>
-              </a:spcAft>
-              <a:defRPr sz="1100" b="1">
-                <a:solidFill>
-                  <a:srgbClr val="0F2942"/>
-                </a:solidFill>
-              </a:defRPr>
-            </a:pPr>
-            <a:r>
-              <a:t>STAGE 2: ENTITY EXTRACTION &amp; GRAPH SYNTHESIS</a:t>
-            </a:r>
-          </a:p>
-          <a:p>
-            <a:pPr>
-              <a:defRPr sz="950">
-                <a:solidFill>
-                  <a:srgbClr val="475569"/>
-                </a:solidFill>
-              </a:defRPr>
-            </a:pPr>
-            <a:r>
-              <a:t>• Hybrid Extractor: Regex rules + Named Entity Recognition (PERSON, PHONE, VEHICLE, ACCOUNT)</a:t>
-            </a:r>
-            <a:br/>
-            <a:r>
-              <a:t>• Entity Resolver: Levenshtein distance &amp; alias disambiguation (90% similarity cutoff)</a:t>
-            </a:r>
-            <a:br/>
-            <a:r>
-              <a:t>• NetworkX Engine: Builds property graph with directed, attributed, temporal relations</a:t>
-            </a:r>
-          </a:p>
-        </p:txBody>
-      </p:sp>
-      <p:sp>
-        <p:nvSpPr>
-          <p:cNvPr id="9" name="Rectangle 8"/>
-          <p:cNvSpPr/>
-          <p:nvPr/>
-        </p:nvSpPr>
-        <p:spPr>
-          <a:xfrm>
-            <a:off x="548640" y="2423160"/>
-            <a:ext cx="137160" cy="1115568"/>
-          </a:xfrm>
-          <a:prstGeom prst="rect">
-            <a:avLst/>
-          </a:prstGeom>
-          <a:solidFill>
-            <a:srgbClr val="0F2942"/>
-          </a:solidFill>
-          <a:ln>
-            <a:noFill/>
-          </a:ln>
-        </p:spPr>
-        <p:style>
-          <a:lnRef idx="1">
-            <a:schemeClr val="accent1"/>
-          </a:lnRef>
-          <a:fillRef idx="3">
-            <a:schemeClr val="accent1"/>
-          </a:fillRef>
-          <a:effectRef idx="2">
-            <a:schemeClr val="accent1"/>
-          </a:effectRef>
-          <a:fontRef idx="minor">
-            <a:schemeClr val="lt1"/>
-          </a:fontRef>
-        </p:style>
-        <p:txBody>
-          <a:bodyPr rtlCol="0" anchor="ctr"/>
-          <a:lstStyle/>
-          <a:p>
-            <a:pPr algn="ctr"/>
-          </a:p>
-        </p:txBody>
-      </p:sp>
-      <p:sp>
-        <p:nvSpPr>
-          <p:cNvPr id="10" name="Rounded Rectangle 9"/>
-          <p:cNvSpPr/>
-          <p:nvPr/>
-        </p:nvSpPr>
-        <p:spPr>
-          <a:xfrm>
-            <a:off x="548640" y="3657600"/>
-            <a:ext cx="8412480" cy="1115568"/>
-          </a:xfrm>
-          <a:prstGeom prst="roundRect">
-            <a:avLst/>
-          </a:prstGeom>
-          <a:solidFill>
-            <a:srgbClr val="FFFFFF"/>
-          </a:solidFill>
-          <a:ln w="19050">
-            <a:solidFill>
-              <a:srgbClr val="CBD5E1"/>
-            </a:solidFill>
-          </a:ln>
-        </p:spPr>
-        <p:style>
-          <a:lnRef idx="1">
-            <a:schemeClr val="accent1"/>
-          </a:lnRef>
-          <a:fillRef idx="3">
-            <a:schemeClr val="accent1"/>
-          </a:fillRef>
-          <a:effectRef idx="2">
-            <a:schemeClr val="accent1"/>
-          </a:effectRef>
-          <a:fontRef idx="minor">
-            <a:schemeClr val="lt1"/>
-          </a:fontRef>
-        </p:style>
-        <p:txBody>
-          <a:bodyPr rtlCol="0" anchor="ctr" wrap="square"/>
-          <a:lstStyle/>
-          <a:p>
-            <a:pPr algn="ctr">
-              <a:spcAft>
-                <a:spcPts val="200"/>
-              </a:spcAft>
-              <a:defRPr sz="1100" b="1">
-                <a:solidFill>
-                  <a:srgbClr val="0F2942"/>
-                </a:solidFill>
-              </a:defRPr>
-            </a:pPr>
-            <a:r>
-              <a:t>STAGE 3: TOPOLOGICAL ANALYTICS &amp; GRAPH MACHINE LEARNING</a:t>
-            </a:r>
-          </a:p>
-          <a:p>
-            <a:pPr>
-              <a:defRPr sz="950">
-                <a:solidFill>
-                  <a:srgbClr val="475569"/>
-                </a:solidFill>
-              </a:defRPr>
-            </a:pPr>
-            <a:r>
-              <a:t>• Centrality Suite: Degree, Betweenness, PageRank, Network Vulnerability Articulation Points</a:t>
-            </a:r>
-            <a:br/>
-            <a:r>
-              <a:t>• Hawala Cycle Detection: Tarjan's elementary cycles identifying 3-to-6 hop smurfing loops</a:t>
-            </a:r>
-            <a:br/>
-            <a:r>
-              <a:t>• Link Prediction: Adamic-Adar, Jaccard, Resource Allocation predicting covert connections</a:t>
-            </a:r>
-            <a:br/>
-            <a:r>
-              <a:t>• Louvain Modularity: Community detection partitioning cartels and logistical cells</a:t>
-            </a:r>
-          </a:p>
-        </p:txBody>
-      </p:sp>
-      <p:sp>
-        <p:nvSpPr>
-          <p:cNvPr id="11" name="Rectangle 10"/>
-          <p:cNvSpPr/>
-          <p:nvPr/>
-        </p:nvSpPr>
-        <p:spPr>
-          <a:xfrm>
-            <a:off x="548640" y="3657600"/>
-            <a:ext cx="137160" cy="1115568"/>
-          </a:xfrm>
-          <a:prstGeom prst="rect">
-            <a:avLst/>
-          </a:prstGeom>
-          <a:solidFill>
-            <a:srgbClr val="109566"/>
-          </a:solidFill>
-          <a:ln>
-            <a:noFill/>
-          </a:ln>
-        </p:spPr>
-        <p:style>
-          <a:lnRef idx="1">
-            <a:schemeClr val="accent1"/>
-          </a:lnRef>
-          <a:fillRef idx="3">
-            <a:schemeClr val="accent1"/>
-          </a:fillRef>
-          <a:effectRef idx="2">
-            <a:schemeClr val="accent1"/>
-          </a:effectRef>
-          <a:fontRef idx="minor">
-            <a:schemeClr val="lt1"/>
-          </a:fontRef>
-        </p:style>
-        <p:txBody>
-          <a:bodyPr rtlCol="0" anchor="ctr"/>
-          <a:lstStyle/>
-          <a:p>
-            <a:pPr algn="ctr"/>
-          </a:p>
-        </p:txBody>
-      </p:sp>
-      <p:sp>
-        <p:nvSpPr>
-          <p:cNvPr id="12" name="Rounded Rectangle 11"/>
-          <p:cNvSpPr/>
-          <p:nvPr/>
-        </p:nvSpPr>
-        <p:spPr>
-          <a:xfrm>
-            <a:off x="548640" y="4892040"/>
-            <a:ext cx="8412480" cy="1115568"/>
-          </a:xfrm>
-          <a:prstGeom prst="roundRect">
-            <a:avLst/>
-          </a:prstGeom>
-          <a:solidFill>
-            <a:srgbClr val="FFFFFF"/>
-          </a:solidFill>
-          <a:ln w="19050">
-            <a:solidFill>
-              <a:srgbClr val="CBD5E1"/>
-            </a:solidFill>
-          </a:ln>
-        </p:spPr>
-        <p:style>
-          <a:lnRef idx="1">
-            <a:schemeClr val="accent1"/>
-          </a:lnRef>
-          <a:fillRef idx="3">
-            <a:schemeClr val="accent1"/>
-          </a:fillRef>
-          <a:effectRef idx="2">
-            <a:schemeClr val="accent1"/>
-          </a:effectRef>
-          <a:fontRef idx="minor">
-            <a:schemeClr val="lt1"/>
-          </a:fontRef>
-        </p:style>
-        <p:txBody>
-          <a:bodyPr rtlCol="0" anchor="ctr" wrap="square"/>
-          <a:lstStyle/>
-          <a:p>
-            <a:pPr algn="ctr">
-              <a:spcAft>
-                <a:spcPts val="200"/>
-              </a:spcAft>
-              <a:defRPr sz="1100" b="1">
-                <a:solidFill>
-                  <a:srgbClr val="0F2942"/>
-                </a:solidFill>
-              </a:defRPr>
-            </a:pPr>
-            <a:r>
-              <a:t>STAGE 4: STATUTORY DECISION-SUPPORT &amp; PRESENTATION LAYER</a:t>
-            </a:r>
-          </a:p>
-          <a:p>
-            <a:pPr>
-              <a:defRPr sz="950">
-                <a:solidFill>
-                  <a:srgbClr val="475569"/>
-                </a:solidFill>
-              </a:defRPr>
-            </a:pPr>
-            <a:r>
-              <a:t>• Investigative Priority Engine: Multi-factor target prioritization with legal disclaimers</a:t>
-            </a:r>
-            <a:br/>
-            <a:r>
-              <a:t>• Interview Preparation Engine: Section 161 CrPC non-leading questions with primary exhibit citations</a:t>
-            </a:r>
-            <a:br/>
-            <a:r>
-              <a:t>• Audio Transcript Panel: Section 65B certified wiretap inspection with audit logging</a:t>
-            </a:r>
-            <a:br/>
-            <a:r>
-              <a:t>• 2D/3D WebGL Canvas: Three.js hardware-accelerated interactive force-directed exploration</a:t>
-            </a:r>
-          </a:p>
-        </p:txBody>
-      </p:sp>
-      <p:sp>
-        <p:nvSpPr>
-          <p:cNvPr id="13" name="Rectangle 12"/>
-          <p:cNvSpPr/>
-          <p:nvPr/>
-        </p:nvSpPr>
-        <p:spPr>
-          <a:xfrm>
-            <a:off x="548640" y="4892040"/>
-            <a:ext cx="137160" cy="1115568"/>
-          </a:xfrm>
-          <a:prstGeom prst="rect">
-            <a:avLst/>
-          </a:prstGeom>
-          <a:solidFill>
-            <a:srgbClr val="0F2942"/>
-          </a:solidFill>
-          <a:ln>
-            <a:noFill/>
-          </a:ln>
-        </p:spPr>
-        <p:style>
-          <a:lnRef idx="1">
-            <a:schemeClr val="accent1"/>
-          </a:lnRef>
-          <a:fillRef idx="3">
-            <a:schemeClr val="accent1"/>
-          </a:fillRef>
-          <a:effectRef idx="2">
-            <a:schemeClr val="accent1"/>
-          </a:effectRef>
-          <a:fontRef idx="minor">
-            <a:schemeClr val="lt1"/>
-          </a:fontRef>
-        </p:style>
-        <p:txBody>
-          <a:bodyPr rtlCol="0" anchor="ctr"/>
-          <a:lstStyle/>
-          <a:p>
-            <a:pPr algn="ctr"/>
-          </a:p>
-        </p:txBody>
-      </p:sp>
-      <p:sp>
-        <p:nvSpPr>
-          <p:cNvPr id="14" name="Rounded Rectangle 13"/>
-          <p:cNvSpPr/>
-          <p:nvPr/>
-        </p:nvSpPr>
-        <p:spPr>
-          <a:xfrm>
-            <a:off x="9235440" y="1188720"/>
-            <a:ext cx="2468880" cy="4892040"/>
-          </a:xfrm>
-          <a:prstGeom prst="roundRect">
-            <a:avLst/>
-          </a:prstGeom>
-          <a:solidFill>
-            <a:srgbClr val="F1F5F9"/>
-          </a:solidFill>
-          <a:ln>
-            <a:solidFill>
-              <a:srgbClr val="CBD5E1"/>
-            </a:solidFill>
-          </a:ln>
-        </p:spPr>
-        <p:style>
-          <a:lnRef idx="1">
-            <a:schemeClr val="accent1"/>
-          </a:lnRef>
-          <a:fillRef idx="3">
-            <a:schemeClr val="accent1"/>
-          </a:fillRef>
-          <a:effectRef idx="2">
-            <a:schemeClr val="accent1"/>
-          </a:effectRef>
-          <a:fontRef idx="minor">
-            <a:schemeClr val="lt1"/>
-          </a:fontRef>
-        </p:style>
-        <p:txBody>
-          <a:bodyPr rtlCol="0" anchor="ctr" wrap="square"/>
-          <a:lstStyle/>
-          <a:p>
-            <a:pPr algn="ctr">
-              <a:spcAft>
-                <a:spcPts val="1000"/>
-              </a:spcAft>
-              <a:defRPr sz="1300" b="1">
-                <a:solidFill>
-                  <a:srgbClr val="0F2942"/>
-                </a:solidFill>
-              </a:defRPr>
-            </a:pPr>
-            <a:r>
-              <a:t>EXACT TOOL STACK</a:t>
-            </a:r>
-          </a:p>
-          <a:p>
-            <a:pPr>
-              <a:spcAft>
-                <a:spcPts val="400"/>
-              </a:spcAft>
-            </a:pPr>
-            <a:r>
-              <a:rPr b="1" sz="1000">
-                <a:solidFill>
-                  <a:srgbClr val="0F2942"/>
-                </a:solidFill>
-              </a:rPr>
-              <a:t>⚙ Python 3.13
-</a:t>
-            </a:r>
-            <a:r>
-              <a:rPr sz="850">
-                <a:solidFill>
-                  <a:srgbClr val="475569"/>
-                </a:solidFill>
-              </a:rPr>
-              <a:t>   Core Backend Language</a:t>
-            </a:r>
-          </a:p>
-          <a:p>
-            <a:pPr>
-              <a:spcAft>
-                <a:spcPts val="400"/>
-              </a:spcAft>
-            </a:pPr>
-            <a:r>
-              <a:rPr b="1" sz="1000">
-                <a:solidFill>
-                  <a:srgbClr val="0F2942"/>
-                </a:solidFill>
-              </a:rPr>
-              <a:t>⚙ FastAPI
-</a:t>
-            </a:r>
-            <a:r>
-              <a:rPr sz="850">
-                <a:solidFill>
-                  <a:srgbClr val="475569"/>
-                </a:solidFill>
-              </a:rPr>
-              <a:t>   High-Speed Async REST API</a:t>
-            </a:r>
-          </a:p>
-          <a:p>
-            <a:pPr>
-              <a:spcAft>
-                <a:spcPts val="400"/>
-              </a:spcAft>
-            </a:pPr>
-            <a:r>
-              <a:rPr b="1" sz="1000">
-                <a:solidFill>
-                  <a:srgbClr val="0F2942"/>
-                </a:solidFill>
-              </a:rPr>
-              <a:t>⚙ NetworkX 3.6
-</a:t>
-            </a:r>
-            <a:r>
-              <a:rPr sz="850">
-                <a:solidFill>
-                  <a:srgbClr val="475569"/>
-                </a:solidFill>
-              </a:rPr>
-              <a:t>   Graph Analytics &amp; Algorithms</a:t>
-            </a:r>
-          </a:p>
-          <a:p>
-            <a:pPr>
-              <a:spcAft>
-                <a:spcPts val="400"/>
-              </a:spcAft>
-            </a:pPr>
-            <a:r>
-              <a:rPr b="1" sz="1000">
-                <a:solidFill>
-                  <a:srgbClr val="0F2942"/>
-                </a:solidFill>
-              </a:rPr>
-              <a:t>⚙ Scikit-Learn 1.9
-</a:t>
-            </a:r>
-            <a:r>
-              <a:rPr sz="850">
-                <a:solidFill>
-                  <a:srgbClr val="475569"/>
-                </a:solidFill>
-              </a:rPr>
-              <a:t>   Bounded ML &amp; Calibration</a:t>
-            </a:r>
-          </a:p>
-          <a:p>
-            <a:pPr>
-              <a:spcAft>
-                <a:spcPts val="400"/>
-              </a:spcAft>
-            </a:pPr>
-            <a:r>
-              <a:rPr b="1" sz="1000">
-                <a:solidFill>
-                  <a:srgbClr val="0F2942"/>
-                </a:solidFill>
-              </a:rPr>
-              <a:t>⚙ React 18 + TS
-</a:t>
-            </a:r>
-            <a:r>
-              <a:rPr sz="850">
-                <a:solidFill>
-                  <a:srgbClr val="475569"/>
-                </a:solidFill>
-              </a:rPr>
-              <a:t>   Investigator HUD Interface</a:t>
-            </a:r>
-          </a:p>
-          <a:p>
-            <a:pPr>
-              <a:spcAft>
-                <a:spcPts val="400"/>
-              </a:spcAft>
-            </a:pPr>
-            <a:r>
-              <a:rPr b="1" sz="1000">
-                <a:solidFill>
-                  <a:srgbClr val="0F2942"/>
-                </a:solidFill>
-              </a:rPr>
-              <a:t>⚙ Three.js / WebGL
-</a:t>
-            </a:r>
-            <a:r>
-              <a:rPr sz="850">
-                <a:solidFill>
-                  <a:srgbClr val="475569"/>
-                </a:solidFill>
-              </a:rPr>
-              <a:t>   3D Graph Hardware Acceleration</a:t>
-            </a:r>
-          </a:p>
-          <a:p>
-            <a:pPr>
-              <a:spcAft>
-                <a:spcPts val="400"/>
-              </a:spcAft>
-            </a:pPr>
-            <a:r>
-              <a:rPr b="1" sz="1000">
-                <a:solidFill>
-                  <a:srgbClr val="0F2942"/>
-                </a:solidFill>
-              </a:rPr>
-              <a:t>⚙ Tailwind CSS
-</a:t>
-            </a:r>
-            <a:r>
-              <a:rPr sz="850">
-                <a:solidFill>
-                  <a:srgbClr val="475569"/>
-                </a:solidFill>
-              </a:rPr>
-              <a:t>   High-Contrast Responsive UI</a:t>
-            </a:r>
-          </a:p>
-          <a:p>
-            <a:pPr>
-              <a:spcAft>
-                <a:spcPts val="400"/>
-              </a:spcAft>
-            </a:pPr>
-            <a:r>
-              <a:rPr b="1" sz="1000">
-                <a:solidFill>
-                  <a:srgbClr val="0F2942"/>
-                </a:solidFill>
-              </a:rPr>
-              <a:t>⚙ SQLite WAL Mode
-</a:t>
-            </a:r>
-            <a:r>
-              <a:rPr sz="850">
-                <a:solidFill>
-                  <a:srgbClr val="475569"/>
-                </a:solidFill>
-              </a:rPr>
-              <a:t>   Zero-Config Forensic Vault</a:t>
-            </a:r>
-          </a:p>
-          <a:p>
-            <a:pPr>
-              <a:spcAft>
-                <a:spcPts val="400"/>
-              </a:spcAft>
-            </a:pPr>
-            <a:r>
-              <a:rPr b="1" sz="1000">
-                <a:solidFill>
-                  <a:srgbClr val="0F2942"/>
-                </a:solidFill>
-              </a:rPr>
-              <a:t>⚙ Pandas &amp; NumPy
-</a:t>
-            </a:r>
-            <a:r>
-              <a:rPr sz="850">
-                <a:solidFill>
-                  <a:srgbClr val="475569"/>
-                </a:solidFill>
-              </a:rPr>
-              <a:t>   Vectorized Telecom Ingestion</a:t>
-            </a:r>
-          </a:p>
-          <a:p>
-            <a:pPr>
-              <a:spcAft>
-                <a:spcPts val="400"/>
-              </a:spcAft>
-            </a:pPr>
-            <a:r>
-              <a:rPr b="1" sz="1000">
-                <a:solidFill>
-                  <a:srgbClr val="0F2942"/>
-                </a:solidFill>
-              </a:rPr>
-              <a:t>⚙ PyPDF
-</a:t>
-            </a:r>
-            <a:r>
-              <a:rPr sz="850">
-                <a:solidFill>
-                  <a:srgbClr val="475569"/>
-                </a:solidFill>
-              </a:rPr>
-              <a:t>   Digital Document Extraction</a:t>
             </a:r>
           </a:p>
         </p:txBody>

</xml_diff>